<commit_message>
Poster changes of 2026-10-15 (Eden's comments): METHODS and README say "Peruvian and Ecuadorian" and the poster's 62 (bootstrap); three figures and the poster copy refreshed
Co-Authored-By: Claude Opus 5.5 <noreply@anthropic.com>
</commit_message>
<xml_diff>
--- a/poster/ASHG2026_Poster_Martin_36x72.pptx
+++ b/poster/ASHG2026_Poster_Martin_36x72.pptx
@@ -503,10 +503,10 @@
             <a:r>
               <a:rPr lang="en-US" dirty="0"/>
               <a:t>LOGISTICS. ASHG 2026, Montréal. Board 1003W, Wednesday 21 Oct, 2:30 to 4:30 PM; set up 9:30 to 10:00 AM; down by 4:30. Canvas 24 x 48 in: print at 150% for 36 x 72 in.
-30 SECONDS. The question: when a blood biomarker reads differently in two populations, is that disease, ancestry, or where the sample was collected, and does it change the test? Three answers. Baselines differ by group for 68 of 126 proteins; the 49 African vs HI-WH differences in cognitively normal adults hold in both reagent lots, and the cohort's own genotypes account for CHIT1 and part of IL6R. The AD signal mostly holds: p-tau rises with AD in every group, and one BD-pTau-217 cut flags the same share of normals everywhere, with fewer clinical AD above it at most African sites. And once site is in the model, few regional differences remain: 10 Andean vs Caribbean, 5 East vs West Africa.
-2 MINUTES. Who and how (10 s): 4,273 participants, 22 sites, 50 countries of birth, four groups, two reagent lots. Site and assay run are random effects; log2 reads and a blood-cell score are covariates; on runs 1332 and 1407 half of each plate's offset in the pooled-plasma control is removed. Each lot is fitted alone because the reagent changed between lots. No single term moves the 49 by more than a median 0.06 log2; site matters most. Section 1 (30 s): 49 proteins differ between African and HI-WH cognitively normal participants; all 49 have the same sign in both lots, Spearman 0.93, median size ratio 0.99; 19 are above 2-fold. Fig 3, left: the ε4 association with p-tau differs by group in the lot 1. Right: the difference this cohort's genotypes predict, beside the one we see: 78% of CHIT1, 45% of IL6R, 15% of TIMP3; ε4 predicts 104% of the APOE4 assay's, the control. 30 of the 49 have no variant in the WGS set; 9 have one that does not move the protein. Section 2 (30 s): p-tau rises with AD in every group in both lots; BD-pTau-217 rises least in African participants in both (0.26 in lot 1, 0.67 in lot 2). 12 group by diagnosis interactions; BD-pTau-217 holds in the lot 2 alone. A BD-pTau-217 cut at the HI-WH normals' 90th percentile flags 5 to 10% of normals in every group; among clinical AD, 30% of African participants are above it vs 43 to 52% in lot 1, 41% vs 62 to 75% in lot 2, and five of eight African sites sit at 31 to 44%. Clinical diagnosis, no amyloid confirmation, so part of that may be diagnosis. Section 3 (15 s): with site in the model, 10 proteins differ Andean vs Caribbean, inside one shared site, and 5 East vs West Africa; six of the 15 are immune; IL6R goes the way rs2228145 predicts. What I'd like from you: a look at the groups you work with, and whether your cut-points travel.
-Q&amp;A CARDS. (1) Ancestry or site? Site is in the model and matters most: without it the African count goes from 49 to 68, HI-MU from 3 to 36. Every 2025 African sample is on run 1332; all 49 keep their sign in the lot 2, where the African samples are on many runs. (2) Is it genetic? Esther's WGS: CHIT1 78%, CCL26 70%, IL6R 45% predicted; CCL2 and CCL17 more predicted than seen (193%, 195%); MME, ARSA, NPY, CCL3, SNCA, VCAM1, ICAM1, IGF1R and SNAP25 have covered variants that move nothing. The 182 African participants with WGS are all in the lot 2 and only 11 genotyped HI-WH are there, so dose cannot be fitted inside a lot. (3) Pre-analytics, blood cells? The blood-cell score is in the model; it moves the 49 by a median 0.03 log2 and took the interactions from 17 to 12. S100A12, SAA1 and FGF2 are among the 49. (4) Fewer p-tau-positive AD at African sites: assay or diagnosis? Same share of normals above the cut; BD-pTau-217 AUC is lower in African participants (0.69 in lot 1, 0.74 in lot 2, vs 0.72 to 0.89 elsewhere); NEFL's AD effect is largest in African participants in lot 1 (0.94). No PET or CSF, so it cannot be settled here. Three African sites (KBTH, CMUL, KATH) sit with the other groups at 50 to 75%. (5) ε4 slope by group: in lot 1, pTau-217 runs from +0.10 in HI-WH (CI through 0) to +0.35 in HI-MU; in lot 2 every group's slope rises except HI-MU, which holds level (+0.35, +0.31). The group difference in slope is a lot-1 result, except BD-pTau-181 (p 0.017 in lot 2). Local ancestry at APOE from the WGS is next. (6) Why is the AD effect larger in lot 2, and which lots differ? The reagent changed between lots, so p-tau is compared within a lot and the 12 do-not-cross markers among the 126 never pool (pTau-217 and BD-pTau-217 among them; 14 on all 131). Of the 49 African differences, 5 disagree between lots (I2 &gt;= 50%: SAA1 83%, CCL26 79%, FGF2 74%, CCL4 67%, IL9 51%) and are not pooled; the other 44 agree, rho 0.93, size ratio 0.99. Lot 1 holds every African sample on run 1332, lot 2 spreads them over 13 sites and many runs, so the lot difference and the run structure are not separable. (7) 68 of 126 with three HI-WH sites? The counts are anti-conservative; a site-level permutation is pending. (8) What is the anchor? The pooled-plasma control read high on runs 1332 and 1407 (a November 2025 bay drift); half of each plate's per-target offset is removed from the study samples on those plates. It moves the 49 by a median 0.03 log2, most for CHIT1.
-DETAIL OFF THE FACE. 65 of 126 differ in cognitively normal adults alone (the plan's estimand; 68 is all diagnoses). Of the 49, FDR &lt; 0.05 in the lot 1 alone 24, in the lot 2 alone 35, in both 18. AD markers among the 49: Aβ42, TARDBP and SNCA lower, GFAP higher; p-tau and NEFL are not among them. Mean ε4 dose at NCI 0.22 / 0.20 / 0.44 / 0.49 (HI-WH / HI-MU / AA / AFR). BD-pTau-217 AD minus NCI: 0.26 to 0.55 (2025), 0.67 to 1.07 (2026). NEFL rises with AD in every group except HI-MU in lot 2 (+0.36, CI from -0.02; 21 AD). Of the 12 interactions, six hold at FDR &lt; 0.05 in the lot 2 alone: ACHE, IL18, TIMP3, BD-pTau-217, IL1B, CXCL1; pTau-217 (p 5e-5) and NEFL (p 6e-4) do not. Aβ42: 7 very low lot-2 values are out (MULH 4; ABTH, COMI, UJTH 1 each; seven runs); with them out, Aβ42 separates AD in no group (AUC 0.37 to 0.61). TREM2: no AD signal in any group, not among the 49. Fig 6 is NPQ with runs 1332 / 1407 anchored. Fig 5: IL6 rests on the lot 2 (the lots disagree, I² 90%). The model-term table, the six-arm interaction matrix and the five-panel Fig 1 go to the supplement.
+30 SECONDS. The question: when a blood biomarker reads differently in two populations, is that disease, ancestry, or where the sample was collected, and does it change the test? Three answers. Baselines differ by group for 62 of 126 proteins; the 49 African vs HI-WH differences in cognitively normal adults hold in both reagent lots, and the cohort's own genotypes account for CHIT1 and part of IL6R. The AD signal mostly holds: p-tau rises with AD in every group, and one BD-pTau-217 cut flags the same share of normals everywhere, with fewer clinical AD above it at most African sites. And once site is in the model, few regional differences remain: 10 Peruvian and Ecuadorian vs Caribbean, 5 East vs West Africa.
+2 MINUTES. Who and how (10 s): 4,273 participants, 22 sites, 50 countries of birth, four groups, two reagent lots. Site and assay run are random effects; log2 reads and a blood-cell score are covariates; on runs 1332 and 1407 half of each plate's offset in the pooled-plasma control is removed. Each lot is fitted alone because the reagent changed between lots. No single term moves the 49 by more than a median 0.06 log2; site matters most. Section 1 (30 s): 49 proteins differ between African and HI-WH cognitively normal participants; all 49 have the same sign in both lots, Spearman 0.93, median size ratio 0.99; 19 are above 2-fold. Fig 3, left: the ε4 association with p-tau differs by group in the lot 1. Right: the difference this cohort's genotypes predict, beside the one we see: 78% of CHIT1, 45% of IL6R, 15% of TIMP3; ε4 predicts 104% of the APOE4 assay's, the control. 30 of the 49 have no variant in the WGS set; 9 have one that does not move the protein. Section 2 (30 s): p-tau rises with AD in every group in both lots; BD-pTau-217 rises least in African participants in both (0.26 in lot 1, 0.67 in lot 2). 12 group by diagnosis interactions; BD-pTau-217 holds in the lot 2 alone. A BD-pTau-217 cut at the HI-WH normals' 90th percentile flags 5 to 10% of normals in every group; among clinical AD, 30% of African participants are above it vs 43 to 52% in lot 1, 41% vs 62 to 75% in lot 2, and five of eight African sites sit at 31 to 44%. Clinical diagnosis, no amyloid confirmation in any group, so how much amyloid pathology each AD group carries is unknown. Section 3 (15 s): with site in the model, 10 proteins differ Peruvian and Ecuadorian vs Caribbean, inside one New York site (53, 25 born in Peru, 27 in Ecuador, 1 in Bolivia, vs 379 Caribbean), and 5 East vs West Africa; six of the 15 are immune; IL6R goes the way rs2228145 predicts. What I'd like from you: a look at the groups you work with, and whether your cut-points travel.
+Q&amp;A CARDS. (1) Ancestry or site? Site is in the model and matters most: without it the African count goes from 49 to 68, HI-MU from 3 to 36. Every 2025 African sample is on run 1332; all 49 keep their sign in the lot 2, where the African samples are on many runs. (2) Is it genetic? Esther's WGS: CHIT1 78%, CCL26 70%, IL6R 45% predicted; CCL2 and CCL17 more predicted than seen (193%, 195%); MME, ARSA, NPY, CCL3, SNCA, VCAM1, ICAM1, IGF1R and SNAP25 have covered variants that move nothing. The 182 African participants with WGS are all in the lot 2 and only 11 genotyped HI-WH are there, so dose cannot be fitted inside a lot. (3) Pre-analytics, blood cells? The blood-cell score is in the model; it moves the 49 by a median 0.03 log2 and took the interactions from 17 to 12. S100A12, SAA1 and FGF2 are among the 49. (4) Fewer p-tau-positive AD at African sites: assay or diagnosis? Same share of normals above the cut; BD-pTau-217 AUC is lower in African participants (0.69 in lot 1, 0.74 in lot 2, vs 0.72 to 0.89 elsewhere); NEFL's AD effect is largest in African participants in lot 1 (0.94). No PET or CSF, so it cannot be settled here. Three African sites (KBTH, CMUL, KATH) sit with the other groups at 50 to 75%. (5) ε4 slope by group: in lot 1, pTau-217 runs from +0.10 in HI-WH (CI through 0) to +0.35 in HI-MU; in lot 2 every group's slope rises except HI-MU, which holds level (+0.35, +0.31). The group difference in slope is a lot-1 result, except BD-pTau-181 (p 0.017 in lot 2). Local ancestry at APOE from the WGS is next. (6) Why is the AD effect larger in lot 2, and which lots differ? The reagent changed between lots, so p-tau is compared within a lot and the 12 do-not-cross markers among the 126 never pool (pTau-217 and BD-pTau-217 among them; 14 on all 131). Of the 49 African differences, 5 disagree between lots (I2 &gt;= 50%: SAA1 83%, CCL26 79%, FGF2 74%, CCL4 67%, IL9 51%) and are not pooled; the other 44 agree, rho 0.93, size ratio 0.99. Lot 1 holds every African sample on run 1332, lot 2 spreads them over 13 sites and many runs, so the lot difference and the run structure are not separable. (7) 62 of 126 with three HI-WH sites? The count is from a parametric bootstrap that redraws the site and run effects under the null, 999 draws per marker and lot, not from the chi-square reference, which gives 68 (the simulated null chi-square runs about 10% above its degrees of freedom). The six the bootstrap loses are at the margin (ACHE, HTT, ICAM1, SAA1, NPTX1, FOLR1; bootstrap p 0.03 to 0.045). Of the 49 African differences, 39 are in the omnibus by the bootstrap, 42 by chi-square. (8) What is the anchor? The pooled-plasma control read high on runs 1332 and 1407 (a November 2025 bay drift); half of each plate's per-target offset is removed from the study samples on those plates. It moves the 49 by a median 0.03 log2, most for CHIT1.
+DETAIL OFF THE FACE. 65 of 126 differ in cognitively normal adults alone (the plan's estimand, by chi-square; all diagnoses: 62 by the bootstrap, 68 by chi-square). Of the 49, FDR &lt; 0.05 in the lot 1 alone 24, in the lot 2 alone 35, in both 18. AD markers among the 49: Aβ42, TARDBP and SNCA lower, GFAP higher; p-tau and NEFL are not among them. Mean ε4 dose at NCI 0.22 / 0.20 / 0.44 / 0.49 (HI-WH / HI-MU / AA / AFR). BD-pTau-217 AD minus NCI: 0.26 to 0.55 (2025), 0.67 to 1.07 (2026). NEFL rises with AD in every group except HI-MU in lot 2 (+0.36, CI from -0.02; 21 AD). Of the 12 interactions, six hold at FDR &lt; 0.05 in the lot 2 alone: ACHE, IL18, TIMP3, BD-pTau-217, IL1B, CXCL1; pTau-217 (p 5e-5) and NEFL (p 6e-4) do not. Aβ42: 7 very low lot-2 values are out (MULH 4; ABTH, COMI, UJTH 1 each; seven runs); with them out, Aβ42 separates AD in no group (AUC 0.37 to 0.61). TREM2: no AD signal in any group, not among the 49. Fig 6 is NPQ with runs 1332 / 1407 anchored. Fig 5: IL6 rests on the lot 2 (the lots disagree, I² 90%). The model-term table, the six-arm interaction matrix and the five-panel Fig 1 go to the supplement.
 Figures: scripts/03_poster_figures.R -&gt; poster/figures_36x72/ (Fig 3b from scripts/15_wgs_pqtl.R). Numbers: output/poster/poster_numbers.txt, output/term_contributions/numbers.txt, output/wgs_pqtl/.</a:t>
             </a:r>
             <a:endParaRPr lang="en-US" dirty="0"/>
@@ -2625,7 +2625,7 @@
                 <a:ea typeface="Arial" pitchFamily="34" charset="-122"/>
                 <a:cs typeface="Arial" pitchFamily="34" charset="-120"/>
               </a:rPr>
-              <a:t>68 of 126 proteins differ; African vs HI-WH 49, all the same sign in both lots</a:t>
+              <a:t>62 of 126 proteins differ; African vs HI-WH 49, all the same sign in both lots</a:t>
             </a:r>
             <a:endParaRPr lang="en-US" sz="3067" dirty="0"/>
           </a:p>
@@ -2793,7 +2793,7 @@
                 <a:ea typeface="Arial" pitchFamily="34" charset="-122"/>
                 <a:cs typeface="Arial" pitchFamily="34" charset="-120"/>
               </a:rPr>
-              <a:t>Andean vs Caribbean 10; East vs West Africa 5</a:t>
+              <a:t>Peruvian and Ecuadorian vs Caribbean 10; East vs West Africa 5</a:t>
             </a:r>
             <a:endParaRPr lang="en-US" sz="3067" dirty="0"/>
           </a:p>
@@ -3687,7 +3687,7 @@
                 <a:ea typeface="Arial" pitchFamily="34" charset="-122"/>
                 <a:cs typeface="Arial" pitchFamily="34" charset="-120"/>
               </a:rPr>
-              <a:t>model: ancestry, sex, age, diagnosis, reads and a blood-cell score, with site and assay run as random effects; full methods in the supplement</a:t>
+              <a:t>model: ancestry, sex, age, diagnosis, reads and a blood-cell score, with site and assay run as random effects; ancestry p-values by parametric bootstrap; full methods in the supplement</a:t>
             </a:r>
             <a:endParaRPr lang="en-US" sz="2400" dirty="0"/>
           </a:p>
@@ -3794,7 +3794,7 @@
                 <a:ea typeface="Arial" pitchFamily="34" charset="-122"/>
                 <a:cs typeface="Arial" pitchFamily="34" charset="-120"/>
               </a:rPr>
-              <a:t>among the cognitively normal, no sign that the ε4 effect on p-tau differs by group (pTau-217 p 0.75 in lot 1, 0.55 in lot 2)</a:t>
+              <a:t>among the cognitively normal, no evidence that the ε4 effect on p-tau differs by group (pTau-217 p 0.75 in lot 1, 0.55 in lot 2)</a:t>
             </a:r>
             <a:endParaRPr lang="en-US" sz="2000" dirty="0"/>
           </a:p>
@@ -3945,7 +3945,7 @@
       </p:sp>
       <p:pic>
         <p:nvPicPr>
-          <p:cNvPr id="49" name="fig2a_afr_caterpillar" descr="The 49 proteins that differ between African and HI-WH cognitively normal participants, ranked from MME and S100A12 (lower in African participants) to ARSA and APOE4 (higher), each with its lot-1 (filled) and lot-2 (hollow) estimate and 95% interval; every protein has the same sign in both lots.">    </p:cNvPr>
+          <p:cNvPr id="49" name="fig2a_afr_caterpillar" descr="The 49 proteins that differ between African and HI-WH cognitively normal participants, ranked from MME and S100A12 (lower in African participants) to ARSA and APOE4 (higher), each with its lot-1 (orange, filled) and lot-2 (navy, hollow) estimate and 95% interval; every protein has the same sign in both lots.">    </p:cNvPr>
           <p:cNvPicPr>
             <a:picLocks noChangeAspect="1"/>
           </p:cNvPicPr>
@@ -3959,8 +3959,8 @@
         </p:blipFill>
         <p:spPr>
           <a:xfrm>
-            <a:off x="13165513" y="7466076"/>
-            <a:ext cx="6688975" cy="4328160"/>
+            <a:off x="13424593" y="7466076"/>
+            <a:ext cx="6170815" cy="3992880"/>
           </a:xfrm>
           <a:prstGeom prst="rect">
             <a:avLst/>
@@ -3975,8 +3975,8 @@
         </p:nvSpPr>
         <p:spPr>
           <a:xfrm>
-            <a:off x="11328400" y="11855196"/>
-            <a:ext cx="10363200" cy="1277112"/>
+            <a:off x="11328400" y="11519916"/>
+            <a:ext cx="10363200" cy="2063496"/>
           </a:xfrm>
           <a:prstGeom prst="rect">
             <a:avLst/>
@@ -4004,7 +4004,7 @@
                 <a:ea typeface="Arial" pitchFamily="34" charset="-122"/>
                 <a:cs typeface="Arial" pitchFamily="34" charset="-120"/>
               </a:rPr>
-              <a:t>68 of 126 differ; vs HI-WH at NCI: African 49, AA 38, HI-MU 3</a:t>
+              <a:t>62 of 126 differ; vs HI-WH at NCI: African 49, AA 38, HI-MU 3</a:t>
             </a:r>
             <a:endParaRPr lang="en-US" sz="2400" dirty="0"/>
           </a:p>
@@ -4029,6 +4029,27 @@
             </a:r>
             <a:endParaRPr lang="en-US" sz="2400" dirty="0"/>
           </a:p>
+          <a:p>
+            <a:pPr marL="304800" indent="-304800">
+              <a:spcAft>
+                <a:spcPts val="576"/>
+              </a:spcAft>
+              <a:buSzPct val="100000"/>
+              <a:buChar char="•"/>
+            </a:pPr>
+            <a:r>
+              <a:rPr lang="en-US" sz="2400" dirty="0">
+                <a:solidFill>
+                  <a:srgbClr val="1A1A1A"/>
+                </a:solidFill>
+                <a:latin typeface="Arial" pitchFamily="34" charset="0"/>
+                <a:ea typeface="Arial" pitchFamily="34" charset="-122"/>
+                <a:cs typeface="Arial" pitchFamily="34" charset="-120"/>
+              </a:rPr>
+              <a:t>HI-MU, Peruvian and Ecuadorian vs Caribbean: 10, all diagnoses, inside one site (section 3)</a:t>
+            </a:r>
+            <a:endParaRPr lang="en-US" sz="2400" dirty="0"/>
+          </a:p>
         </p:txBody>
       </p:sp>
       <p:sp>
@@ -4039,7 +4060,7 @@
         </p:nvSpPr>
         <p:spPr>
           <a:xfrm>
-            <a:off x="11328400" y="13284708"/>
+            <a:off x="11328400" y="13735812"/>
             <a:ext cx="10363200" cy="832104"/>
           </a:xfrm>
           <a:prstGeom prst="rect">
@@ -4086,8 +4107,8 @@
         </p:blipFill>
         <p:spPr>
           <a:xfrm>
-            <a:off x="13647783" y="14177772"/>
-            <a:ext cx="5724434" cy="3535680"/>
+            <a:off x="13894526" y="14628876"/>
+            <a:ext cx="5230949" cy="3230880"/>
           </a:xfrm>
           <a:prstGeom prst="rect">
             <a:avLst/>
@@ -4102,7 +4123,7 @@
         </p:nvSpPr>
         <p:spPr>
           <a:xfrm>
-            <a:off x="11328400" y="17713452"/>
+            <a:off x="11328400" y="17859756"/>
             <a:ext cx="10363200" cy="1606296"/>
           </a:xfrm>
           <a:prstGeom prst="rect">
@@ -4498,7 +4519,7 @@
                 <a:ea typeface="Arial" pitchFamily="34" charset="-122"/>
                 <a:cs typeface="Arial" pitchFamily="34" charset="-120"/>
               </a:rPr>
-              <a:t>With site in the model, 10 proteins differ Andean vs Caribbean and 5 East vs West Africa; 6 of the 15 are immune</a:t>
+              <a:t>With site in the model, 10 proteins differ Peruvian and Ecuadorian vs Caribbean and 5 East vs West Africa; 6 of the 15 are immune</a:t>
             </a:r>
             <a:endParaRPr lang="en-US" sz="2800" dirty="0"/>
           </a:p>
@@ -4506,7 +4527,7 @@
       </p:sp>
       <p:pic>
         <p:nvPicPr>
-          <p:cNvPr id="65" name="fig5_regional" descr="Proteins that differ by region with site accounted for, lot 1 filled and lot 2 hollow, coloured by function. Left, Andean minus Caribbean within one site: IL6R, IL6, CCL17, SAA1, IL13, PDGFRB, VEGFA, TAFA5, MME, CST3. Right, East minus West Africa with site in the model: CCL13, NPTX1, YWHAZ, MSLN, FOLR1.">    </p:cNvPr>
+          <p:cNvPr id="65" name="fig5_regional" descr="Proteins that differ by region with site accounted for, lot 1 filled and lot 2 hollow, coloured by function. Left, Peruvian and Ecuadorian minus Caribbean within one site: IL6R, IL6, CCL17, SAA1, IL13, PDGFRB, VEGFA, TAFA5, MME, CST3. Right, East minus West Africa with site in the model: CCL13, NPTX1, YWHAZ, MSLN, FOLR1.">    </p:cNvPr>
           <p:cNvPicPr>
             <a:picLocks noChangeAspect="1"/>
           </p:cNvPicPr>
@@ -4520,8 +4541,8 @@
         </p:blipFill>
         <p:spPr>
           <a:xfrm>
-            <a:off x="33070800" y="7882128"/>
-            <a:ext cx="10363200" cy="5486400"/>
+            <a:off x="33108223" y="7882128"/>
+            <a:ext cx="10288355" cy="5446776"/>
           </a:xfrm>
           <a:prstGeom prst="rect">
             <a:avLst/>
@@ -4536,8 +4557,8 @@
         </p:nvSpPr>
         <p:spPr>
           <a:xfrm>
-            <a:off x="33070800" y="13429488"/>
-            <a:ext cx="10363200" cy="1277112"/>
+            <a:off x="33070800" y="13389864"/>
+            <a:ext cx="10363200" cy="1633728"/>
           </a:xfrm>
           <a:prstGeom prst="rect">
             <a:avLst/>
@@ -4565,7 +4586,7 @@
                 <a:ea typeface="Arial" pitchFamily="34" charset="-122"/>
                 <a:cs typeface="Arial" pitchFamily="34" charset="-120"/>
               </a:rPr>
-              <a:t>197 of 260 Andean are at Peru: compared within one shared site</a:t>
+              <a:t>197 of 260 are at the Peru site: compared within one New York site</a:t>
             </a:r>
             <a:endParaRPr lang="en-US" sz="2400" dirty="0"/>
           </a:p>
@@ -4586,7 +4607,7 @@
                 <a:ea typeface="Arial" pitchFamily="34" charset="-122"/>
                 <a:cs typeface="Arial" pitchFamily="34" charset="-120"/>
               </a:rPr>
-              <a:t>IL6R higher in Andean participants, as rs2228145-C predicts (gnomAD: Latino 0.53, European 0.40, African 0.13)</a:t>
+              <a:t>IL6R higher in Peruvian and Ecuadorian, as rs2228145-C predicts (gnomAD: Latino 0.53, European 0.40, African 0.13)</a:t>
             </a:r>
             <a:endParaRPr lang="en-US" sz="2400" dirty="0"/>
           </a:p>
@@ -4600,7 +4621,7 @@
         </p:nvSpPr>
         <p:spPr>
           <a:xfrm>
-            <a:off x="33070800" y="14859000"/>
+            <a:off x="33070800" y="15175992"/>
             <a:ext cx="10363200" cy="2205228"/>
           </a:xfrm>
           <a:prstGeom prst="rect">
@@ -4625,7 +4646,7 @@
         </p:nvSpPr>
         <p:spPr>
           <a:xfrm>
-            <a:off x="33314640" y="15072360"/>
+            <a:off x="33314640" y="15389352"/>
             <a:ext cx="9875520" cy="335280"/>
           </a:xfrm>
           <a:prstGeom prst="rect">
@@ -4664,7 +4685,7 @@
         </p:nvSpPr>
         <p:spPr>
           <a:xfrm>
-            <a:off x="33314640" y="15430500"/>
+            <a:off x="33314640" y="15747492"/>
             <a:ext cx="9875520" cy="1542288"/>
           </a:xfrm>
           <a:prstGeom prst="rect">
@@ -4770,7 +4791,7 @@
         </p:nvSpPr>
         <p:spPr>
           <a:xfrm>
-            <a:off x="33070800" y="17247108"/>
+            <a:off x="33070800" y="17564100"/>
             <a:ext cx="10363200" cy="1912620"/>
           </a:xfrm>
           <a:prstGeom prst="rect">
@@ -4795,7 +4816,7 @@
         </p:nvSpPr>
         <p:spPr>
           <a:xfrm>
-            <a:off x="33314640" y="17429988"/>
+            <a:off x="33314640" y="17746980"/>
             <a:ext cx="8168640" cy="335280"/>
           </a:xfrm>
           <a:prstGeom prst="rect">
@@ -4834,7 +4855,7 @@
         </p:nvSpPr>
         <p:spPr>
           <a:xfrm>
-            <a:off x="33314640" y="17788128"/>
+            <a:off x="33314640" y="18105120"/>
             <a:ext cx="8168640" cy="1249680"/>
           </a:xfrm>
           <a:prstGeom prst="rect">
@@ -4881,7 +4902,7 @@
         </p:blipFill>
         <p:spPr>
           <a:xfrm>
-            <a:off x="41818560" y="17471898"/>
+            <a:off x="41818560" y="17788890"/>
             <a:ext cx="1463040" cy="1463040"/>
           </a:xfrm>
           <a:prstGeom prst="rect">
@@ -4970,7 +4991,7 @@
                 <a:ea typeface="Arial" pitchFamily="34" charset="-122"/>
                 <a:cs typeface="Arial" pitchFamily="34" charset="-120"/>
               </a:rPr>
-              <a:t>A cut-point that travels, and a clinical diagnosis that may not.</a:t>
+              <a:t>Normals cross the cut-point equally in every group; clinical AD does not.</a:t>
             </a:r>
             <a:endParaRPr lang="en-US" sz="1733" dirty="0"/>
           </a:p>
@@ -4987,7 +5008,7 @@
                 <a:ea typeface="Arial" pitchFamily="34" charset="-122"/>
                 <a:cs typeface="Arial" pitchFamily="34" charset="-120"/>
               </a:rPr>
-              <a:t>p-tau: one cut flags the same share of normals everywhere; check diagnosis at African sites before recalibrating   ·   Aβ42 alone does not separate AD in any group   ·   a one-site population difference is a site difference until shown otherwise</a:t>
+              <a:t>p-tau: confirm AD with amyloid in every group before recalibrating the cut-point   ·   Aβ42 alone does not separate AD in any group   ·   a one-site population difference is a site difference until shown otherwise</a:t>
             </a:r>
             <a:endParaRPr lang="en-US" sz="1733" dirty="0"/>
           </a:p>

</xml_diff>

<commit_message>
METHODS names the six the site-level bootstrap drops; genotype figure (dashed line in the key) and the poster copy refreshed (2026-10-15, second round)
Co-Authored-By: Claude Opus 5.5 <noreply@anthropic.com>
</commit_message>
<xml_diff>
--- a/poster/ASHG2026_Poster_Martin_36x72.pptx
+++ b/poster/ASHG2026_Poster_Martin_36x72.pptx
@@ -505,7 +505,7 @@
               <a:t>LOGISTICS. ASHG 2026, Montréal. Board 1003W, Wednesday 21 Oct, 2:30 to 4:30 PM; set up 9:30 to 10:00 AM; down by 4:30. Canvas 24 x 48 in: print at 150% for 36 x 72 in.
 30 SECONDS. The question: when a blood biomarker reads differently in two populations, is that disease, ancestry, or where the sample was collected, and does it change the test? Three answers. Baselines differ by group for 62 of 126 proteins; the 49 African vs HI-WH differences in cognitively normal adults hold in both reagent lots, and the cohort's own genotypes account for CHIT1 and part of IL6R. The AD signal mostly holds: p-tau rises with AD in every group, and one BD-pTau-217 cut flags the same share of normals everywhere, with fewer clinical AD above it at most African sites. And once site is in the model, few regional differences remain: 10 Peruvian and Ecuadorian vs Caribbean, 5 East vs West Africa.
 2 MINUTES. Who and how (10 s): 4,273 participants, 22 sites, 50 countries of birth, four groups, two reagent lots. Site and assay run are random effects; log2 reads and a blood-cell score are covariates; on runs 1332 and 1407 half of each plate's offset in the pooled-plasma control is removed. Each lot is fitted alone because the reagent changed between lots. No single term moves the 49 by more than a median 0.06 log2; site matters most. Section 1 (30 s): 49 proteins differ between African and HI-WH cognitively normal participants; all 49 have the same sign in both lots, Spearman 0.93, median size ratio 0.99; 19 are above 2-fold. Fig 3, left: the ε4 association with p-tau differs by group in the lot 1. Right: the difference this cohort's genotypes predict, beside the one we see: 78% of CHIT1, 45% of IL6R, 15% of TIMP3; ε4 predicts 104% of the APOE4 assay's, the control. 30 of the 49 have no variant in the WGS set; 9 have one that does not move the protein. Section 2 (30 s): p-tau rises with AD in every group in both lots; BD-pTau-217 rises least in African participants in both (0.26 in lot 1, 0.67 in lot 2). 12 group by diagnosis interactions; BD-pTau-217 holds in the lot 2 alone. A BD-pTau-217 cut at the HI-WH normals' 90th percentile flags 5 to 10% of normals in every group; among clinical AD, 30% of African participants are above it vs 43 to 52% in lot 1, 41% vs 62 to 75% in lot 2, and five of eight African sites sit at 31 to 44%. Clinical diagnosis, no amyloid confirmation in any group, so how much amyloid pathology each AD group carries is unknown. Section 3 (15 s): with site in the model, 10 proteins differ Peruvian and Ecuadorian vs Caribbean, inside one New York site (53, 25 born in Peru, 27 in Ecuador, 1 in Bolivia, vs 379 Caribbean), and 5 East vs West Africa; six of the 15 are immune; IL6R goes the way rs2228145 predicts. What I'd like from you: a look at the groups you work with, and whether your cut-points travel.
-Q&amp;A CARDS. (1) Ancestry or site? Site is in the model and matters most: without it the African count goes from 49 to 68, HI-MU from 3 to 36. Every 2025 African sample is on run 1332; all 49 keep their sign in the lot 2, where the African samples are on many runs. (2) Is it genetic? Esther's WGS: CHIT1 78%, CCL26 70%, IL6R 45% predicted; CCL2 and CCL17 more predicted than seen (193%, 195%); MME, ARSA, NPY, CCL3, SNCA, VCAM1, ICAM1, IGF1R and SNAP25 have covered variants that move nothing. The 182 African participants with WGS are all in the lot 2 and only 11 genotyped HI-WH are there, so dose cannot be fitted inside a lot. (3) Pre-analytics, blood cells? The blood-cell score is in the model; it moves the 49 by a median 0.03 log2 and took the interactions from 17 to 12. S100A12, SAA1 and FGF2 are among the 49. (4) Fewer p-tau-positive AD at African sites: assay or diagnosis? Same share of normals above the cut; BD-pTau-217 AUC is lower in African participants (0.69 in lot 1, 0.74 in lot 2, vs 0.72 to 0.89 elsewhere); NEFL's AD effect is largest in African participants in lot 1 (0.94). No PET or CSF, so it cannot be settled here. Three African sites (KBTH, CMUL, KATH) sit with the other groups at 50 to 75%. (5) ε4 slope by group: in lot 1, pTau-217 runs from +0.10 in HI-WH (CI through 0) to +0.35 in HI-MU; in lot 2 every group's slope rises except HI-MU, which holds level (+0.35, +0.31). The group difference in slope is a lot-1 result, except BD-pTau-181 (p 0.017 in lot 2). Local ancestry at APOE from the WGS is next. (6) Why is the AD effect larger in lot 2, and which lots differ? The reagent changed between lots, so p-tau is compared within a lot and the 12 do-not-cross markers among the 126 never pool (pTau-217 and BD-pTau-217 among them; 14 on all 131). Of the 49 African differences, 5 disagree between lots (I2 &gt;= 50%: SAA1 83%, CCL26 79%, FGF2 74%, CCL4 67%, IL9 51%) and are not pooled; the other 44 agree, rho 0.93, size ratio 0.99. Lot 1 holds every African sample on run 1332, lot 2 spreads them over 13 sites and many runs, so the lot difference and the run structure are not separable. (7) 62 of 126 with three HI-WH sites? The count is from a parametric bootstrap that redraws the site and run effects under the null, 999 draws per marker and lot, not from the chi-square reference, which gives 68 (the simulated null chi-square runs about 10% above its degrees of freedom). The six the bootstrap loses are at the margin (ACHE, HTT, ICAM1, SAA1, NPTX1, FOLR1; bootstrap p 0.03 to 0.045). Of the 49 African differences, 39 are in the omnibus by the bootstrap, 42 by chi-square. (8) What is the anchor? The pooled-plasma control read high on runs 1332 and 1407 (a November 2025 bay drift); half of each plate's per-target offset is removed from the study samples on those plates. It moves the 49 by a median 0.03 log2, most for CHIT1.
+Q&amp;A CARDS. (1) Ancestry or site? Site is in the model and matters most: without it the African count goes from 49 to 68, HI-MU from 3 to 36. Every 2025 African sample is on run 1332; all 49 keep their sign in the lot 2, where the African samples are on many runs. (2) Is it genetic? Esther's WGS: CHIT1 78%, CCL26 70%, IL6R 45% predicted; CCL2 and CCL17 more predicted than seen (193%, 195%); MME, ARSA, NPY, CCL3, SNCA, VCAM1, ICAM1, IGF1R and SNAP25 have covered variants that move nothing. The 182 African participants with WGS are all in the lot 2 and only 11 genotyped HI-WH are there, so dose cannot be fitted inside a lot. (3) Pre-analytics, blood cells? The blood-cell score is in the model; it moves the 49 by a median 0.03 log2 and took the interactions from 17 to 12. S100A12, SAA1 and FGF2 are among the 49. (4) Fewer p-tau-positive AD at African sites: assay or diagnosis? Same share of normals above the cut; BD-pTau-217 AUC is lower in African participants (0.69 in lot 1, 0.74 in lot 2, vs 0.72 to 0.89 elsewhere); NEFL's AD effect is largest in African participants in lot 1 (0.94). No PET or CSF, so it cannot be settled here. Three African sites (KBTH, CMUL, KATH) sit with the other groups at 50 to 75%. (5) ε4 slope by group: in lot 1, pTau-217 runs from +0.10 in HI-WH (CI through 0) to +0.35 in HI-MU; in lot 2 every group's slope rises except HI-MU, which holds level (+0.35, +0.31). The group difference in slope is a lot-1 result, except BD-pTau-181 (p 0.017 in lot 2). Local ancestry at APOE from the WGS is next. (6) Why is the AD effect larger in lot 2, and which lots differ? The reagent changed between lots, so p-tau is compared within a lot and the 12 do-not-cross markers among the 126 never pool (pTau-217 and BD-pTau-217 among them; 14 on all 131). Of the 49 African differences, 5 disagree between lots (I2 &gt;= 50%: SAA1 83%, CCL26 79%, FGF2 74%, CCL4 67%, IL9 51%) and are not pooled; the other 44 agree, rho 0.93, size ratio 0.99. Lot 1 holds every African sample on run 1332, lot 2 spreads them over 13 sites and many runs, so the lot difference and the run structure are not separable. (7) 62 of 126 with three HI-WH sites? The count is from a parametric bootstrap that redraws the site and run effects under the null, 999 draws per marker and lot, not from the chi-square reference, which gives 68 (the simulated null chi-square runs about 10% above its degrees of freedom). The six the bootstrap loses are at the margin (ACHE, HTT, ICAM1, SAA1, NPTX1, FOLR1; bootstrap p 0.03 to 0.045). Of the 49 African differences, 39 are in the omnibus by the bootstrap, 42 by chi-square. (8) What is the anchor? The pooled-plasma control read high on runs 1332 and 1407 (a November 2025 bay drift); half of each plate's per-target offset is removed from the study samples on those plates. It moves the 49 by a median 0.03 log2, most for CHIT1. (9) What does your Aβ show? Not amyloid status: plasma Aβ42/40 is 0.14 log2 lower in clinical AD than in normals, the same in every group, but it barely separates them (AUC 0.44 to 0.65 by group and lot), and Aβ42 alone does no better. That is why the next step is amyloid PET or CSF, in every group.
 DETAIL OFF THE FACE. 65 of 126 differ in cognitively normal adults alone (the plan's estimand, by chi-square; all diagnoses: 62 by the bootstrap, 68 by chi-square). Of the 49, FDR &lt; 0.05 in the lot 1 alone 24, in the lot 2 alone 35, in both 18. AD markers among the 49: Aβ42, TARDBP and SNCA lower, GFAP higher; p-tau and NEFL are not among them. Mean ε4 dose at NCI 0.22 / 0.20 / 0.44 / 0.49 (HI-WH / HI-MU / AA / AFR). BD-pTau-217 AD minus NCI: 0.26 to 0.55 (2025), 0.67 to 1.07 (2026). NEFL rises with AD in every group except HI-MU in lot 2 (+0.36, CI from -0.02; 21 AD). Of the 12 interactions, six hold at FDR &lt; 0.05 in the lot 2 alone: ACHE, IL18, TIMP3, BD-pTau-217, IL1B, CXCL1; pTau-217 (p 5e-5) and NEFL (p 6e-4) do not. Aβ42: 7 very low lot-2 values are out (MULH 4; ABTH, COMI, UJTH 1 each; seven runs); with them out, Aβ42 separates AD in no group (AUC 0.37 to 0.61). TREM2: no AD signal in any group, not among the 49. Fig 6 is NPQ with runs 1332 / 1407 anchored. Fig 5: IL6 rests on the lot 2 (the lots disagree, I² 90%). The model-term table, the six-arm interaction matrix and the five-panel Fig 1 go to the supplement.
 Figures: scripts/03_poster_figures.R -&gt; poster/figures_36x72/ (Fig 3b from scripts/15_wgs_pqtl.R). Numbers: output/poster/poster_numbers.txt, output/term_contributions/numbers.txt, output/wgs_pqtl/.</a:t>
             </a:r>
@@ -4735,7 +4735,7 @@
                 <a:ea typeface="Arial" pitchFamily="34" charset="-122"/>
                 <a:cs typeface="Arial" pitchFamily="34" charset="-120"/>
               </a:rPr>
-              <a:t>groups: self-identified (US) or country of birth (Africa)</a:t>
+              <a:t>groups: self-identified (US) or born in Africa; no genetic PCs</a:t>
             </a:r>
             <a:endParaRPr lang="en-US" sz="2000" dirty="0"/>
           </a:p>
@@ -5008,7 +5008,7 @@
                 <a:ea typeface="Arial" pitchFamily="34" charset="-122"/>
                 <a:cs typeface="Arial" pitchFamily="34" charset="-120"/>
               </a:rPr>
-              <a:t>p-tau: confirm AD with amyloid in every group before recalibrating the cut-point   ·   Aβ42 alone does not separate AD in any group   ·   a one-site population difference is a site difference until shown otherwise</a:t>
+              <a:t>p-tau: confirm AD with amyloid PET or CSF in every group before recalibrating the cut-point   ·   plasma Aβ42 and Aβ42/40 do not separate AD in any group   ·   a one-site population difference is a site difference until shown otherwise</a:t>
             </a:r>
             <a:endParaRPr lang="en-US" sz="1733" dirty="0"/>
           </a:p>

</xml_diff>

<commit_message>
Third round of 2026-10-15: Fig 2a as bars, the diagnosis-stage figure (fig4b_stage_by_group; the AD minus NCI figure stays here), Fig 5 with the all-sites contrast and the old one-site figure by lot, the genotype figure's trimmed axis; README and METHODS (test 6, the all-sites contrast) follow; poster copy refreshed
Co-Authored-By: Claude Opus 5.5 <noreply@anthropic.com>
</commit_message>
<xml_diff>
--- a/poster/ASHG2026_Poster_Martin_36x72.pptx
+++ b/poster/ASHG2026_Poster_Martin_36x72.pptx
@@ -504,7 +504,7 @@
               <a:rPr lang="en-US" dirty="0"/>
               <a:t>LOGISTICS. ASHG 2026, Montréal. Board 1003W, Wednesday 21 Oct, 2:30 to 4:30 PM; set up 9:30 to 10:00 AM; down by 4:30. Canvas 24 x 48 in: print at 150% for 36 x 72 in.
 30 SECONDS. The question: when a blood biomarker reads differently in two populations, is that disease, ancestry, or where the sample was collected, and does it change the test? Three answers. Baselines differ by group for 62 of 126 proteins; the 49 African vs HI-WH differences in cognitively normal adults hold in both reagent lots, and the cohort's own genotypes account for CHIT1 and part of IL6R. The AD signal mostly holds: p-tau rises with AD in every group, and one BD-pTau-217 cut flags the same share of normals everywhere, with fewer clinical AD above it at most African sites. And once site is in the model, few regional differences remain: 10 Peruvian and Ecuadorian vs Caribbean, 5 East vs West Africa.
-2 MINUTES. Who and how (10 s): 4,273 participants, 22 sites, 50 countries of birth, four groups, two reagent lots. Site and assay run are random effects; log2 reads and a blood-cell score are covariates; on runs 1332 and 1407 half of each plate's offset in the pooled-plasma control is removed. Each lot is fitted alone because the reagent changed between lots. No single term moves the 49 by more than a median 0.06 log2; site matters most. Section 1 (30 s): 49 proteins differ between African and HI-WH cognitively normal participants; all 49 have the same sign in both lots, Spearman 0.93, median size ratio 0.99; 19 are above 2-fold. Fig 3, left: the ε4 association with p-tau differs by group in the lot 1. Right: the difference this cohort's genotypes predict, beside the one we see: 78% of CHIT1, 45% of IL6R, 15% of TIMP3; ε4 predicts 104% of the APOE4 assay's, the control. 30 of the 49 have no variant in the WGS set; 9 have one that does not move the protein. Section 2 (30 s): p-tau rises with AD in every group in both lots; BD-pTau-217 rises least in African participants in both (0.26 in lot 1, 0.67 in lot 2). 12 group by diagnosis interactions; BD-pTau-217 holds in the lot 2 alone. A BD-pTau-217 cut at the HI-WH normals' 90th percentile flags 5 to 10% of normals in every group; among clinical AD, 30% of African participants are above it vs 43 to 52% in lot 1, 41% vs 62 to 75% in lot 2, and five of eight African sites sit at 31 to 44%. Clinical diagnosis, no amyloid confirmation in any group, so how much amyloid pathology each AD group carries is unknown. Section 3 (15 s): with site in the model, 10 proteins differ Peruvian and Ecuadorian vs Caribbean, inside one New York site (53, 25 born in Peru, 27 in Ecuador, 1 in Bolivia, vs 379 Caribbean), and 5 East vs West Africa; six of the 15 are immune; IL6R goes the way rs2228145 predicts. What I'd like from you: a look at the groups you work with, and whether your cut-points travel.
+2 MINUTES. Who and how (10 s): 4,273 participants, 22 sites, 50 countries of birth, four groups, two reagent lots. Site and assay run are random effects; log2 reads and a blood-cell score are covariates; on runs 1332 and 1407 half of each plate's offset in the pooled-plasma control is removed. Each lot is fitted alone because the reagent changed between lots. No single term moves the 49 by more than a median 0.06 log2; site matters most. Section 1 (30 s): 49 proteins differ between African and HI-WH cognitively normal participants; all 49 have the same sign in both lots, Spearman 0.93, median size ratio 0.99; 19 are above 2-fold. Fig 3, left: the ε4 association with p-tau differs by group in the lot 1. Right: the difference this cohort's genotypes predict, beside the one we see: 78% of CHIT1, 45% of IL6R, 15% of TIMP3; ε4 predicts 104% of the APOE4 assay's, the control. 30 of the 49 have no variant in the WGS set; 9 have one that does not move the protein. Section 2 (30 s): p-tau rises from NCI through MCI to AD in every group in both lots (different people at each stage, so it reads like a trajectory without being one); BD-pTau-217 rises least in African participants in both (0.26 in lot 1, 0.67 in lot 2). 12 group by diagnosis interactions; BD-pTau-217 holds in the lot 2 alone. A BD-pTau-217 cut at the HI-WH normals' 90th percentile flags 5 to 10% of normals in every group; among clinical AD, 30% of African participants are above it vs 43 to 52% in lot 1, 41% vs 62 to 75% in lot 2, and five of eight African sites sit at 31 to 44%. Clinical diagnosis, no amyloid confirmation in any group, so how much amyloid pathology each AD group carries is unknown. Section 3 (15 s): Peruvian and Ecuadorian vs Caribbean, 10 proteins differ inside one New York site (53, 25 born in Peru, 27 in Ecuador, 1 in Bolivia, vs 379 Caribbean). Across all three sites it's 22, but the 14 extra are all higher in Peruvian and Ecuadorian participants, and the Peru site has no Caribbean participants, so there I can't separate site from origin. East vs West Africa, 5; six of the 15 that hold with site separated are immune; IL6R goes the way rs2228145 predicts (gnomAD, the C allele: Latino 0.53, European 0.40, African 0.13). What I'd like from you: a look at the groups you work with, and whether your cut-points travel.
 Q&amp;A CARDS. (1) Ancestry or site? Site is in the model and matters most: without it the African count goes from 49 to 68, HI-MU from 3 to 36. Every 2025 African sample is on run 1332; all 49 keep their sign in the lot 2, where the African samples are on many runs. (2) Is it genetic? Esther's WGS: CHIT1 78%, CCL26 70%, IL6R 45% predicted; CCL2 and CCL17 more predicted than seen (193%, 195%); MME, ARSA, NPY, CCL3, SNCA, VCAM1, ICAM1, IGF1R and SNAP25 have covered variants that move nothing. The 182 African participants with WGS are all in the lot 2 and only 11 genotyped HI-WH are there, so dose cannot be fitted inside a lot. (3) Pre-analytics, blood cells? The blood-cell score is in the model; it moves the 49 by a median 0.03 log2 and took the interactions from 17 to 12. S100A12, SAA1 and FGF2 are among the 49. (4) Fewer p-tau-positive AD at African sites: assay or diagnosis? Same share of normals above the cut; BD-pTau-217 AUC is lower in African participants (0.69 in lot 1, 0.74 in lot 2, vs 0.72 to 0.89 elsewhere); NEFL's AD effect is largest in African participants in lot 1 (0.94). No PET or CSF, so it cannot be settled here. Three African sites (KBTH, CMUL, KATH) sit with the other groups at 50 to 75%. (5) ε4 slope by group: in lot 1, pTau-217 runs from +0.10 in HI-WH (CI through 0) to +0.35 in HI-MU; in lot 2 every group's slope rises except HI-MU, which holds level (+0.35, +0.31). The group difference in slope is a lot-1 result, except BD-pTau-181 (p 0.017 in lot 2). Local ancestry at APOE from the WGS is next. (6) Why is the AD effect larger in lot 2, and which lots differ? The reagent changed between lots, so p-tau is compared within a lot and the 12 do-not-cross markers among the 126 never pool (pTau-217 and BD-pTau-217 among them; 14 on all 131). Of the 49 African differences, 5 disagree between lots (I2 &gt;= 50%: SAA1 83%, CCL26 79%, FGF2 74%, CCL4 67%, IL9 51%) and are not pooled; the other 44 agree, rho 0.93, size ratio 0.99. Lot 1 holds every African sample on run 1332, lot 2 spreads them over 13 sites and many runs, so the lot difference and the run structure are not separable. (7) 62 of 126 with three HI-WH sites? The count is from a parametric bootstrap that redraws the site and run effects under the null, 999 draws per marker and lot, not from the chi-square reference, which gives 68 (the simulated null chi-square runs about 10% above its degrees of freedom). The six the bootstrap loses are at the margin (ACHE, HTT, ICAM1, SAA1, NPTX1, FOLR1; bootstrap p 0.03 to 0.045). Of the 49 African differences, 39 are in the omnibus by the bootstrap, 42 by chi-square. (8) What is the anchor? The pooled-plasma control read high on runs 1332 and 1407 (a November 2025 bay drift); half of each plate's per-target offset is removed from the study samples on those plates. It moves the 49 by a median 0.03 log2, most for CHIT1. (9) What does your Aβ show? Not amyloid status: plasma Aβ42/40 is 0.14 log2 lower in clinical AD than in normals, the same in every group, but it barely separates them (AUC 0.44 to 0.65 by group and lot), and Aβ42 alone does no better. That is why the next step is amyloid PET or CSF, in every group.
 DETAIL OFF THE FACE. 65 of 126 differ in cognitively normal adults alone (the plan's estimand, by chi-square; all diagnoses: 62 by the bootstrap, 68 by chi-square). Of the 49, FDR &lt; 0.05 in the lot 1 alone 24, in the lot 2 alone 35, in both 18. AD markers among the 49: Aβ42, TARDBP and SNCA lower, GFAP higher; p-tau and NEFL are not among them. Mean ε4 dose at NCI 0.22 / 0.20 / 0.44 / 0.49 (HI-WH / HI-MU / AA / AFR). BD-pTau-217 AD minus NCI: 0.26 to 0.55 (2025), 0.67 to 1.07 (2026). NEFL rises with AD in every group except HI-MU in lot 2 (+0.36, CI from -0.02; 21 AD). Of the 12 interactions, six hold at FDR &lt; 0.05 in the lot 2 alone: ACHE, IL18, TIMP3, BD-pTau-217, IL1B, CXCL1; pTau-217 (p 5e-5) and NEFL (p 6e-4) do not. Aβ42: 7 very low lot-2 values are out (MULH 4; ABTH, COMI, UJTH 1 each; seven runs); with them out, Aβ42 separates AD in no group (AUC 0.37 to 0.61). TREM2: no AD signal in any group, not among the 49. Fig 6 is NPQ with runs 1332 / 1407 anchored. Fig 5: IL6 rests on the lot 2 (the lots disagree, I² 90%). The model-term table, the six-arm interaction matrix and the five-panel Fig 1 go to the supplement.
 Figures: scripts/03_poster_figures.R -&gt; poster/figures_36x72/ (Fig 3b from scripts/15_wgs_pqtl.R). Numbers: output/poster/poster_numbers.txt, output/term_contributions/numbers.txt, output/wgs_pqtl/.</a:t>
@@ -3945,7 +3945,7 @@
       </p:sp>
       <p:pic>
         <p:nvPicPr>
-          <p:cNvPr id="49" name="fig2a_afr_caterpillar" descr="The 49 proteins that differ between African and HI-WH cognitively normal participants, ranked from MME and S100A12 (lower in African participants) to ARSA and APOE4 (higher), each with its lot-1 (orange, filled) and lot-2 (navy, hollow) estimate and 95% interval; every protein has the same sign in both lots.">    </p:cNvPr>
+          <p:cNvPr id="49" name="fig2a_afr_caterpillar" descr="The 49 proteins that differ between African and HI-WH cognitively normal participants, ranked from MME and S100A12 (lower in African participants) to ARSA and APOE4 (higher), each with a bar for the main-model estimate and a dot for each lot (lot 1 orange, filled; lot 2 navy, hollow); every protein has the same sign in both lots.">    </p:cNvPr>
           <p:cNvPicPr>
             <a:picLocks noChangeAspect="1"/>
           </p:cNvPicPr>
@@ -4046,7 +4046,7 @@
                 <a:ea typeface="Arial" pitchFamily="34" charset="-122"/>
                 <a:cs typeface="Arial" pitchFamily="34" charset="-120"/>
               </a:rPr>
-              <a:t>HI-MU, Peruvian and Ecuadorian vs Caribbean: 10, all diagnoses, inside one site (section 3)</a:t>
+              <a:t>HI-MU, Peruvian and Ecuadorian vs Caribbean: 10 in one site, 22 across three (section 3)</a:t>
             </a:r>
             <a:endParaRPr lang="en-US" sz="2400" dirty="0"/>
           </a:p>
@@ -4225,7 +4225,7 @@
         <p:spPr>
           <a:xfrm>
             <a:off x="22199600" y="6573012"/>
-            <a:ext cx="10363200" cy="832104"/>
+            <a:ext cx="10363200" cy="1248156"/>
           </a:xfrm>
           <a:prstGeom prst="rect">
             <a:avLst/>
@@ -4249,7 +4249,7 @@
                 <a:ea typeface="Arial" pitchFamily="34" charset="-122"/>
                 <a:cs typeface="Arial" pitchFamily="34" charset="-120"/>
               </a:rPr>
-              <a:t>p-tau rises with AD in every group, in both lots; BD-pTau-217 rises least in African participants</a:t>
+              <a:t>p-tau rises from NCI through MCI to AD in every group, in both lots; BD-pTau-217 rises least in African participants</a:t>
             </a:r>
             <a:endParaRPr lang="en-US" sz="2800" dirty="0"/>
           </a:p>
@@ -4257,7 +4257,7 @@
       </p:sp>
       <p:pic>
         <p:nvPicPr>
-          <p:cNvPr id="57" name="fig4b_ad_effect_by_group" descr="AD minus cognitively normal difference within each group, lot 1 filled and lot 2 hollow, for eight markers: BD-pTau-217, pTau-217, BD-pTau-181 and NEFL rise in every group, BD-pTau-217 least in African participants; Abeta42, TREM2, pSNCA-129 and SNCA show no AD signal.">    </p:cNvPr>
+          <p:cNvPr id="57" name="fig4b_stage_by_group" descr="Level at each diagnosis stage, NCI, MCI and AD, in each group, relative to HI-WH cognitively normal, for pTau-217, BD-pTau-217, NEFL and GFAP; lot 1 in the top row, lot 2 below. p-tau rises from NCI to AD in every group, least in African participants; NEFL and GFAP rise in every group.">    </p:cNvPr>
           <p:cNvPicPr>
             <a:picLocks noChangeAspect="1"/>
           </p:cNvPicPr>
@@ -4271,8 +4271,8 @@
         </p:blipFill>
         <p:spPr>
           <a:xfrm>
-            <a:off x="22199600" y="7466076"/>
-            <a:ext cx="10363200" cy="4754880"/>
+            <a:off x="22199600" y="7882128"/>
+            <a:ext cx="10363200" cy="4267200"/>
           </a:xfrm>
           <a:prstGeom prst="rect">
             <a:avLst/>
@@ -4287,7 +4287,46 @@
         </p:nvSpPr>
         <p:spPr>
           <a:xfrm>
-            <a:off x="22199600" y="12281916"/>
+            <a:off x="22199600" y="12149328"/>
+            <a:ext cx="10363200" cy="318516"/>
+          </a:xfrm>
+          <a:prstGeom prst="rect">
+            <a:avLst/>
+          </a:prstGeom>
+          <a:noFill/>
+          <a:ln/>
+        </p:spPr>
+        <p:txBody>
+          <a:bodyPr wrap="square" lIns="0" tIns="0" rIns="0" bIns="0" rtlCol="0" anchor="t"/>
+          <a:lstStyle/>
+          <a:p>
+            <a:pPr indent="0" marL="0">
+              <a:buNone/>
+            </a:pPr>
+            <a:r>
+              <a:rPr lang="en-US" sz="1733" dirty="0">
+                <a:solidFill>
+                  <a:srgbClr val="4A4A4A"/>
+                </a:solidFill>
+                <a:latin typeface="Arial" pitchFamily="34" charset="0"/>
+                <a:ea typeface="Arial" pitchFamily="34" charset="-122"/>
+                <a:cs typeface="Arial" pitchFamily="34" charset="-120"/>
+              </a:rPr>
+              <a:t>Cross-sectional: different people at each stage, not one person followed over time.</a:t>
+            </a:r>
+            <a:endParaRPr lang="en-US" sz="1733" dirty="0"/>
+          </a:p>
+        </p:txBody>
+      </p:sp>
+      <p:sp>
+        <p:nvSpPr>
+          <p:cNvPr id="59" name="Text 46"/>
+          <p:cNvSpPr txBox="1"/>
+          <p:nvPr/>
+        </p:nvSpPr>
+        <p:spPr>
+          <a:xfrm>
+            <a:off x="22199600" y="12528804"/>
             <a:ext cx="10363200" cy="847344"/>
           </a:xfrm>
           <a:prstGeom prst="rect">
@@ -4324,13 +4363,13 @@
       </p:sp>
       <p:sp>
         <p:nvSpPr>
-          <p:cNvPr id="59" name="Text 46"/>
+          <p:cNvPr id="60" name="Text 47"/>
           <p:cNvSpPr txBox="1"/>
           <p:nvPr/>
         </p:nvSpPr>
         <p:spPr>
           <a:xfrm>
-            <a:off x="22199600" y="13281660"/>
+            <a:off x="22199600" y="13528548"/>
             <a:ext cx="10363200" cy="832104"/>
           </a:xfrm>
           <a:prstGeom prst="rect">
@@ -4363,7 +4402,7 @@
       </p:sp>
       <p:pic>
         <p:nvPicPr>
-          <p:cNvPr id="60" name="fig6_cutpoint_by_group" descr="Percent of clinical AD (filled) and cognitively normal (hollow) participants above a cut-point set at the HI-WH normals' 90th percentile within lot, by group, for five markers in each lot; for BD-pTau-217 the normals sit at 5 to 10 percent in every group, and fewer African participants with clinical AD are above the cut.">    </p:cNvPr>
+          <p:cNvPr id="61" name="fig6_cutpoint_by_group" descr="Percent of clinical AD (filled) and cognitively normal (hollow) participants above a cut-point set at the HI-WH normals' 90th percentile within lot, by group, for five markers in each lot; for BD-pTau-217 the normals sit at 5 to 10 percent in every group, and fewer African participants with clinical AD are above the cut.">    </p:cNvPr>
           <p:cNvPicPr>
             <a:picLocks noChangeAspect="1"/>
           </p:cNvPicPr>
@@ -4377,7 +4416,7 @@
         </p:blipFill>
         <p:spPr>
           <a:xfrm>
-            <a:off x="22199600" y="14174724"/>
+            <a:off x="22199600" y="14421612"/>
             <a:ext cx="10363200" cy="3901440"/>
           </a:xfrm>
           <a:prstGeom prst="rect">
@@ -4387,13 +4426,13 @@
       </p:pic>
       <p:sp>
         <p:nvSpPr>
-          <p:cNvPr id="61" name="Text 47"/>
+          <p:cNvPr id="62" name="Text 48"/>
           <p:cNvSpPr txBox="1"/>
           <p:nvPr/>
         </p:nvSpPr>
         <p:spPr>
           <a:xfrm>
-            <a:off x="22199600" y="18076164"/>
+            <a:off x="22199600" y="18323052"/>
             <a:ext cx="10363200" cy="1091184"/>
           </a:xfrm>
           <a:prstGeom prst="rect">
@@ -4426,7 +4465,7 @@
       </p:sp>
       <p:sp>
         <p:nvSpPr>
-          <p:cNvPr id="62" name="Text 48"/>
+          <p:cNvPr id="63" name="Text 49"/>
           <p:cNvSpPr txBox="1"/>
           <p:nvPr/>
         </p:nvSpPr>
@@ -4465,7 +4504,7 @@
       </p:sp>
       <p:sp>
         <p:nvSpPr>
-          <p:cNvPr id="63" name="Shape 49"/>
+          <p:cNvPr id="64" name="Shape 50"/>
           <p:cNvSpPr/>
           <p:nvPr/>
         </p:nvSpPr>
@@ -4488,7 +4527,7 @@
       </p:sp>
       <p:sp>
         <p:nvSpPr>
-          <p:cNvPr id="64" name="Text 50"/>
+          <p:cNvPr id="65" name="Text 51"/>
           <p:cNvSpPr txBox="1"/>
           <p:nvPr/>
         </p:nvSpPr>
@@ -4519,7 +4558,7 @@
                 <a:ea typeface="Arial" pitchFamily="34" charset="-122"/>
                 <a:cs typeface="Arial" pitchFamily="34" charset="-120"/>
               </a:rPr>
-              <a:t>With site in the model, 10 proteins differ Peruvian and Ecuadorian vs Caribbean and 5 East vs West Africa; 6 of the 15 are immune</a:t>
+              <a:t>Peruvian and Ecuadorian vs Caribbean: 10 differ inside one New York site; 22 across three sites, where the Peru site and Peruvian origin cannot be separated</a:t>
             </a:r>
             <a:endParaRPr lang="en-US" sz="2800" dirty="0"/>
           </a:p>
@@ -4527,7 +4566,7 @@
       </p:sp>
       <p:pic>
         <p:nvPicPr>
-          <p:cNvPr id="65" name="fig5_regional" descr="Proteins that differ by region with site accounted for, lot 1 filled and lot 2 hollow, coloured by function. Left, Peruvian and Ecuadorian minus Caribbean within one site: IL6R, IL6, CCL17, SAA1, IL13, PDGFRB, VEGFA, TAFA5, MME, CST3. Right, East minus West Africa with site in the model: CCL13, NPTX1, YWHAZ, MSLN, FOLR1.">    </p:cNvPr>
+          <p:cNvPr id="66" name="fig5_regional" descr="Left, Peruvian and Ecuadorian minus Caribbean among HI-MU: 24 proteins, each with the estimate over all sites, site in the model (filled), and inside one New York site (hollow); the 10 that differ inside the one site have bold names coloured by function (IL13, CCL17, SAA1, TAFA5, VEGFA, CST3, IL6, IL6R, PDGFRB, MME), the 14 that differ only across sites are grey. Right, East minus West Africa with site in the model: CCL13, MSLN, FOLR1, NPTX1, YWHAZ.">    </p:cNvPr>
           <p:cNvPicPr>
             <a:picLocks noChangeAspect="1"/>
           </p:cNvPicPr>
@@ -4541,8 +4580,8 @@
         </p:blipFill>
         <p:spPr>
           <a:xfrm>
-            <a:off x="33108223" y="7882128"/>
-            <a:ext cx="10288355" cy="5446776"/>
+            <a:off x="33135570" y="7882128"/>
+            <a:ext cx="10233660" cy="5417820"/>
           </a:xfrm>
           <a:prstGeom prst="rect">
             <a:avLst/>
@@ -4551,14 +4590,53 @@
       </p:pic>
       <p:sp>
         <p:nvSpPr>
-          <p:cNvPr id="66" name="Text 51"/>
+          <p:cNvPr id="67" name="Text 52"/>
           <p:cNvSpPr txBox="1"/>
           <p:nvPr/>
         </p:nvSpPr>
         <p:spPr>
           <a:xfrm>
-            <a:off x="33070800" y="13389864"/>
-            <a:ext cx="10363200" cy="1633728"/>
+            <a:off x="33070800" y="13299948"/>
+            <a:ext cx="10363200" cy="833628"/>
+          </a:xfrm>
+          <a:prstGeom prst="rect">
+            <a:avLst/>
+          </a:prstGeom>
+          <a:noFill/>
+          <a:ln/>
+        </p:spPr>
+        <p:txBody>
+          <a:bodyPr wrap="square" lIns="0" tIns="0" rIns="0" bIns="0" rtlCol="0" anchor="t"/>
+          <a:lstStyle/>
+          <a:p>
+            <a:pPr indent="0" marL="0">
+              <a:buNone/>
+            </a:pPr>
+            <a:r>
+              <a:rPr lang="en-US" sz="1733" dirty="0">
+                <a:solidFill>
+                  <a:srgbClr val="4A4A4A"/>
+                </a:solidFill>
+                <a:latin typeface="Arial" pitchFamily="34" charset="0"/>
+                <a:ea typeface="Arial" pitchFamily="34" charset="-122"/>
+                <a:cs typeface="Arial" pitchFamily="34" charset="-120"/>
+              </a:rPr>
+              <a:t>Filled: all sites, site in the model (848 HI-MU); hollow: the New York site alone, 53 vs 379. The Peru site holds 197 of the 260 Peruvian and Ecuadorian and no Caribbean; the 14 grey names are all higher in Peruvian and Ecuadorian.</a:t>
+            </a:r>
+            <a:endParaRPr lang="en-US" sz="1733" dirty="0"/>
+          </a:p>
+        </p:txBody>
+      </p:sp>
+      <p:sp>
+        <p:nvSpPr>
+          <p:cNvPr id="68" name="Text 53"/>
+          <p:cNvSpPr txBox="1"/>
+          <p:nvPr/>
+        </p:nvSpPr>
+        <p:spPr>
+          <a:xfrm>
+            <a:off x="33070800" y="14194536"/>
+            <a:ext cx="10363200" cy="920496"/>
           </a:xfrm>
           <a:prstGeom prst="rect">
             <a:avLst/>
@@ -4586,7 +4664,7 @@
                 <a:ea typeface="Arial" pitchFamily="34" charset="-122"/>
                 <a:cs typeface="Arial" pitchFamily="34" charset="-120"/>
               </a:rPr>
-              <a:t>197 of 260 are at the Peru site: compared within one New York site</a:t>
+              <a:t>East vs West Africa 5; of the 15 bold names, 6 are immune</a:t>
             </a:r>
             <a:endParaRPr lang="en-US" sz="2400" dirty="0"/>
           </a:p>
@@ -4607,7 +4685,7 @@
                 <a:ea typeface="Arial" pitchFamily="34" charset="-122"/>
                 <a:cs typeface="Arial" pitchFamily="34" charset="-120"/>
               </a:rPr>
-              <a:t>IL6R higher in Peruvian and Ecuadorian, as rs2228145-C predicts (gnomAD: Latino 0.53, European 0.40, African 0.13)</a:t>
+              <a:t>IL6R higher in Peruvian and Ecuadorian, as rs2228145 predicts</a:t>
             </a:r>
             <a:endParaRPr lang="en-US" sz="2400" dirty="0"/>
           </a:p>
@@ -4615,13 +4693,13 @@
       </p:sp>
       <p:sp>
         <p:nvSpPr>
-          <p:cNvPr id="67" name="CAVEATS"/>
+          <p:cNvPr id="69" name="CAVEATS"/>
           <p:cNvSpPr/>
           <p:nvPr/>
         </p:nvSpPr>
         <p:spPr>
           <a:xfrm>
-            <a:off x="33070800" y="15175992"/>
+            <a:off x="33070800" y="15206472"/>
             <a:ext cx="10363200" cy="2205228"/>
           </a:xfrm>
           <a:prstGeom prst="rect">
@@ -4640,13 +4718,13 @@
       </p:sp>
       <p:sp>
         <p:nvSpPr>
-          <p:cNvPr id="68" name="Text 53"/>
+          <p:cNvPr id="70" name="Text 55"/>
           <p:cNvSpPr txBox="1"/>
           <p:nvPr/>
         </p:nvSpPr>
         <p:spPr>
           <a:xfrm>
-            <a:off x="33314640" y="15389352"/>
+            <a:off x="33314640" y="15419832"/>
             <a:ext cx="9875520" cy="335280"/>
           </a:xfrm>
           <a:prstGeom prst="rect">
@@ -4679,13 +4757,13 @@
       </p:sp>
       <p:sp>
         <p:nvSpPr>
-          <p:cNvPr id="69" name="Text 54"/>
+          <p:cNvPr id="71" name="Text 56"/>
           <p:cNvSpPr txBox="1"/>
           <p:nvPr/>
         </p:nvSpPr>
         <p:spPr>
           <a:xfrm>
-            <a:off x="33314640" y="15747492"/>
+            <a:off x="33314640" y="15777972"/>
             <a:ext cx="9875520" cy="1542288"/>
           </a:xfrm>
           <a:prstGeom prst="rect">
@@ -4785,7 +4863,7 @@
       </p:sp>
       <p:sp>
         <p:nvSpPr>
-          <p:cNvPr id="70" name="SUPPLEMENT"/>
+          <p:cNvPr id="72" name="SUPPLEMENT"/>
           <p:cNvSpPr/>
           <p:nvPr/>
         </p:nvSpPr>
@@ -4810,7 +4888,7 @@
       </p:sp>
       <p:sp>
         <p:nvSpPr>
-          <p:cNvPr id="71" name="Text 56"/>
+          <p:cNvPr id="73" name="Text 58"/>
           <p:cNvSpPr txBox="1"/>
           <p:nvPr/>
         </p:nvSpPr>
@@ -4849,7 +4927,7 @@
       </p:sp>
       <p:sp>
         <p:nvSpPr>
-          <p:cNvPr id="72" name="Text 57"/>
+          <p:cNvPr id="74" name="Text 59"/>
           <p:cNvSpPr txBox="1"/>
           <p:nvPr/>
         </p:nvSpPr>
@@ -4888,7 +4966,7 @@
       </p:sp>
       <p:pic>
         <p:nvPicPr>
-          <p:cNvPr id="73" name="QR supplement" descr="QR code to the public supplement at github.com/emartin-um/ASHG2026-supplement">    </p:cNvPr>
+          <p:cNvPr id="75" name="QR supplement" descr="QR code to the public supplement at github.com/emartin-um/ASHG2026-supplement">    </p:cNvPr>
           <p:cNvPicPr>
             <a:picLocks noChangeAspect="1"/>
           </p:cNvPicPr>
@@ -4912,7 +4990,7 @@
       </p:pic>
       <p:sp>
         <p:nvSpPr>
-          <p:cNvPr id="74" name="what this means"/>
+          <p:cNvPr id="76" name="what this means"/>
           <p:cNvSpPr/>
           <p:nvPr/>
         </p:nvSpPr>
@@ -4937,7 +5015,7 @@
       </p:sp>
       <p:sp>
         <p:nvSpPr>
-          <p:cNvPr id="75" name="Text 59"/>
+          <p:cNvPr id="77" name="Text 61"/>
           <p:cNvSpPr txBox="1"/>
           <p:nvPr/>
         </p:nvSpPr>
@@ -5016,7 +5094,7 @@
       </p:sp>
       <p:sp>
         <p:nvSpPr>
-          <p:cNvPr id="76" name="Text 60"/>
+          <p:cNvPr id="78" name="Text 62"/>
           <p:cNvSpPr txBox="1"/>
           <p:nvPr/>
         </p:nvSpPr>

</xml_diff>

<commit_message>
Poster copy refreshed: the Universidad Central del Caribe seal in the header
Co-Authored-By: Claude Opus 5.5 <noreply@anthropic.com>
</commit_message>
<xml_diff>
--- a/poster/ASHG2026_Poster_Martin_36x72.pptx
+++ b/poster/ASHG2026_Poster_Martin_36x72.pptx
@@ -2337,7 +2337,7 @@
         </p:blipFill>
         <p:spPr>
           <a:xfrm>
-            <a:off x="39766847" y="972312"/>
+            <a:off x="39644927" y="972312"/>
             <a:ext cx="1422400" cy="280416"/>
           </a:xfrm>
           <a:prstGeom prst="rect">
@@ -2361,7 +2361,7 @@
         </p:blipFill>
         <p:spPr>
           <a:xfrm>
-            <a:off x="41494047" y="990600"/>
+            <a:off x="41250207" y="990600"/>
             <a:ext cx="1642132" cy="243840"/>
           </a:xfrm>
           <a:prstGeom prst="rect">
@@ -2369,9 +2369,33 @@
           </a:prstGeom>
         </p:spPr>
       </p:pic>
-      <p:sp>
-        <p:nvSpPr>
-          <p:cNvPr id="13" name="Text 4"/>
+      <p:pic>
+        <p:nvPicPr>
+          <p:cNvPr id="13" name="logo uccshield" descr="Universidad Central del Caribe, Puerto Rico">    </p:cNvPr>
+          <p:cNvPicPr>
+            <a:picLocks noChangeAspect="1"/>
+          </p:cNvPicPr>
+          <p:nvPr/>
+        </p:nvPicPr>
+        <p:blipFill>
+          <a:blip r:embed="rId8"/>
+          <a:stretch>
+            <a:fillRect/>
+          </a:stretch>
+        </p:blipFill>
+        <p:spPr>
+          <a:xfrm>
+            <a:off x="43075218" y="944880"/>
+            <a:ext cx="336965" cy="335280"/>
+          </a:xfrm>
+          <a:prstGeom prst="rect">
+            <a:avLst/>
+          </a:prstGeom>
+        </p:spPr>
+      </p:pic>
+      <p:sp>
+        <p:nvSpPr>
+          <p:cNvPr id="14" name="Text 4"/>
           <p:cNvSpPr txBox="1"/>
           <p:nvPr/>
         </p:nvSpPr>
@@ -2424,7 +2448,7 @@
       </p:sp>
       <p:sp>
         <p:nvSpPr>
-          <p:cNvPr id="14" name="answer band"/>
+          <p:cNvPr id="15" name="answer band"/>
           <p:cNvSpPr/>
           <p:nvPr/>
         </p:nvSpPr>
@@ -2449,7 +2473,7 @@
       </p:sp>
       <p:sp>
         <p:nvSpPr>
-          <p:cNvPr id="15" name="Text 6"/>
+          <p:cNvPr id="16" name="Text 6"/>
           <p:cNvSpPr txBox="1"/>
           <p:nvPr/>
         </p:nvSpPr>
@@ -2508,7 +2532,7 @@
       </p:sp>
       <p:sp>
         <p:nvSpPr>
-          <p:cNvPr id="16" name="Shape 7"/>
+          <p:cNvPr id="17" name="Shape 7"/>
           <p:cNvSpPr/>
           <p:nvPr/>
         </p:nvSpPr>
@@ -2531,7 +2555,7 @@
       </p:sp>
       <p:sp>
         <p:nvSpPr>
-          <p:cNvPr id="17" name="Text 8"/>
+          <p:cNvPr id="18" name="Text 8"/>
           <p:cNvSpPr txBox="1"/>
           <p:nvPr/>
         </p:nvSpPr>
@@ -2570,7 +2594,7 @@
       </p:sp>
       <p:sp>
         <p:nvSpPr>
-          <p:cNvPr id="18" name="Text 9"/>
+          <p:cNvPr id="19" name="Text 9"/>
           <p:cNvSpPr txBox="1"/>
           <p:nvPr/>
         </p:nvSpPr>
@@ -2654,7 +2678,7 @@
       </p:sp>
       <p:sp>
         <p:nvSpPr>
-          <p:cNvPr id="19" name="Text 10"/>
+          <p:cNvPr id="20" name="Text 10"/>
           <p:cNvSpPr txBox="1"/>
           <p:nvPr/>
         </p:nvSpPr>
@@ -2738,7 +2762,7 @@
       </p:sp>
       <p:sp>
         <p:nvSpPr>
-          <p:cNvPr id="20" name="Text 11"/>
+          <p:cNvPr id="21" name="Text 11"/>
           <p:cNvSpPr txBox="1"/>
           <p:nvPr/>
         </p:nvSpPr>
@@ -2822,7 +2846,7 @@
       </p:sp>
       <p:sp>
         <p:nvSpPr>
-          <p:cNvPr id="21" name="Text 12"/>
+          <p:cNvPr id="22" name="Text 12"/>
           <p:cNvSpPr txBox="1"/>
           <p:nvPr/>
         </p:nvSpPr>
@@ -2861,7 +2885,7 @@
       </p:sp>
       <p:sp>
         <p:nvSpPr>
-          <p:cNvPr id="22" name="Shape 13"/>
+          <p:cNvPr id="23" name="Shape 13"/>
           <p:cNvSpPr/>
           <p:nvPr/>
         </p:nvSpPr>
@@ -2884,7 +2908,7 @@
       </p:sp>
       <p:sp>
         <p:nvSpPr>
-          <p:cNvPr id="23" name="Text 14"/>
+          <p:cNvPr id="24" name="Text 14"/>
           <p:cNvSpPr txBox="1"/>
           <p:nvPr/>
         </p:nvSpPr>
@@ -2923,7 +2947,7 @@
       </p:sp>
       <p:sp>
         <p:nvSpPr>
-          <p:cNvPr id="24" name="Text 15"/>
+          <p:cNvPr id="25" name="Text 15"/>
           <p:cNvSpPr txBox="1"/>
           <p:nvPr/>
         </p:nvSpPr>
@@ -2962,7 +2986,7 @@
       </p:sp>
       <p:sp>
         <p:nvSpPr>
-          <p:cNvPr id="25" name="Text 16"/>
+          <p:cNvPr id="26" name="Text 16"/>
           <p:cNvSpPr txBox="1"/>
           <p:nvPr/>
         </p:nvSpPr>
@@ -3001,7 +3025,7 @@
       </p:sp>
       <p:sp>
         <p:nvSpPr>
-          <p:cNvPr id="26" name="Text 17"/>
+          <p:cNvPr id="27" name="Text 17"/>
           <p:cNvSpPr txBox="1"/>
           <p:nvPr/>
         </p:nvSpPr>
@@ -3040,7 +3064,7 @@
       </p:sp>
       <p:sp>
         <p:nvSpPr>
-          <p:cNvPr id="27" name="Text 18"/>
+          <p:cNvPr id="28" name="Text 18"/>
           <p:cNvSpPr txBox="1"/>
           <p:nvPr/>
         </p:nvSpPr>
@@ -3079,7 +3103,7 @@
       </p:sp>
       <p:sp>
         <p:nvSpPr>
-          <p:cNvPr id="28" name="Text 19"/>
+          <p:cNvPr id="29" name="Text 19"/>
           <p:cNvSpPr txBox="1"/>
           <p:nvPr/>
         </p:nvSpPr>
@@ -3118,7 +3142,7 @@
       </p:sp>
       <p:sp>
         <p:nvSpPr>
-          <p:cNvPr id="29" name="Text 20"/>
+          <p:cNvPr id="30" name="Text 20"/>
           <p:cNvSpPr txBox="1"/>
           <p:nvPr/>
         </p:nvSpPr>
@@ -3157,7 +3181,7 @@
       </p:sp>
       <p:sp>
         <p:nvSpPr>
-          <p:cNvPr id="30" name="Text 21"/>
+          <p:cNvPr id="31" name="Text 21"/>
           <p:cNvSpPr txBox="1"/>
           <p:nvPr/>
         </p:nvSpPr>
@@ -3196,14 +3220,14 @@
       </p:sp>
       <p:pic>
         <p:nvPicPr>
-          <p:cNvPr id="31" name="fig1_cohort" descr="Three panels by ancestry group: participants by clinical diagnosis (616 HI-WH, 998 HI-MU, 1,669 AA, 990 African); birthplace as a percent of each group (most HI-WH and HI-MU born in the Caribbean, every African participant in Africa); participants by recruitment place, US sites by state, Peru, and African sites by country.">    </p:cNvPr>
+          <p:cNvPr id="32" name="fig1_cohort" descr="Three panels by ancestry group: participants by clinical diagnosis (616 HI-WH, 998 HI-MU, 1,669 AA, 990 African); birthplace as a percent of each group (most HI-WH and HI-MU born in the Caribbean, every African participant in Africa); participants by recruitment place, US sites by state, Peru, and African sites by country.">    </p:cNvPr>
           <p:cNvPicPr>
             <a:picLocks noChangeAspect="1"/>
           </p:cNvPicPr>
           <p:nvPr/>
         </p:nvPicPr>
         <p:blipFill>
-          <a:blip r:embed="rId8"/>
+          <a:blip r:embed="rId9"/>
           <a:stretch>
             <a:fillRect/>
           </a:stretch>
@@ -3220,7 +3244,7 @@
       </p:pic>
       <p:sp>
         <p:nvSpPr>
-          <p:cNvPr id="32" name="Text 22"/>
+          <p:cNvPr id="33" name="Text 22"/>
           <p:cNvSpPr txBox="1"/>
           <p:nvPr/>
         </p:nvSpPr>
@@ -3259,7 +3283,7 @@
       </p:sp>
       <p:sp>
         <p:nvSpPr>
-          <p:cNvPr id="33" name="key chip HI-WH"/>
+          <p:cNvPr id="34" name="key chip HI-WH"/>
           <p:cNvSpPr/>
           <p:nvPr/>
         </p:nvSpPr>
@@ -3284,7 +3308,7 @@
       </p:sp>
       <p:sp>
         <p:nvSpPr>
-          <p:cNvPr id="34" name="Text 24"/>
+          <p:cNvPr id="35" name="Text 24"/>
           <p:cNvSpPr txBox="1"/>
           <p:nvPr/>
         </p:nvSpPr>
@@ -3337,7 +3361,7 @@
       </p:sp>
       <p:sp>
         <p:nvSpPr>
-          <p:cNvPr id="35" name="key chip HI-MU"/>
+          <p:cNvPr id="36" name="key chip HI-MU"/>
           <p:cNvSpPr/>
           <p:nvPr/>
         </p:nvSpPr>
@@ -3362,7 +3386,7 @@
       </p:sp>
       <p:sp>
         <p:nvSpPr>
-          <p:cNvPr id="36" name="Text 26"/>
+          <p:cNvPr id="37" name="Text 26"/>
           <p:cNvSpPr txBox="1"/>
           <p:nvPr/>
         </p:nvSpPr>
@@ -3415,7 +3439,7 @@
       </p:sp>
       <p:sp>
         <p:nvSpPr>
-          <p:cNvPr id="37" name="key chip AA"/>
+          <p:cNvPr id="38" name="key chip AA"/>
           <p:cNvSpPr/>
           <p:nvPr/>
         </p:nvSpPr>
@@ -3440,7 +3464,7 @@
       </p:sp>
       <p:sp>
         <p:nvSpPr>
-          <p:cNvPr id="38" name="Text 28"/>
+          <p:cNvPr id="39" name="Text 28"/>
           <p:cNvSpPr txBox="1"/>
           <p:nvPr/>
         </p:nvSpPr>
@@ -3493,7 +3517,7 @@
       </p:sp>
       <p:sp>
         <p:nvSpPr>
-          <p:cNvPr id="39" name="key chip AFR"/>
+          <p:cNvPr id="40" name="key chip AFR"/>
           <p:cNvSpPr/>
           <p:nvPr/>
         </p:nvSpPr>
@@ -3518,7 +3542,7 @@
       </p:sp>
       <p:sp>
         <p:nvSpPr>
-          <p:cNvPr id="40" name="Text 30"/>
+          <p:cNvPr id="41" name="Text 30"/>
           <p:cNvSpPr txBox="1"/>
           <p:nvPr/>
         </p:nvSpPr>
@@ -3571,7 +3595,7 @@
       </p:sp>
       <p:sp>
         <p:nvSpPr>
-          <p:cNvPr id="41" name="Text 31"/>
+          <p:cNvPr id="42" name="Text 31"/>
           <p:cNvSpPr txBox="1"/>
           <p:nvPr/>
         </p:nvSpPr>
@@ -3610,7 +3634,7 @@
       </p:sp>
       <p:sp>
         <p:nvSpPr>
-          <p:cNvPr id="42" name="Text 32"/>
+          <p:cNvPr id="43" name="Text 32"/>
           <p:cNvSpPr txBox="1"/>
           <p:nvPr/>
         </p:nvSpPr>
@@ -3695,7 +3719,7 @@
       </p:sp>
       <p:sp>
         <p:nvSpPr>
-          <p:cNvPr id="43" name="APOE ε4: THE COUNTER-EXAMPLE"/>
+          <p:cNvPr id="44" name="APOE ε4: THE COUNTER-EXAMPLE"/>
           <p:cNvSpPr/>
           <p:nvPr/>
         </p:nvSpPr>
@@ -3720,7 +3744,7 @@
       </p:sp>
       <p:sp>
         <p:nvSpPr>
-          <p:cNvPr id="44" name="Text 34"/>
+          <p:cNvPr id="45" name="Text 34"/>
           <p:cNvSpPr txBox="1"/>
           <p:nvPr/>
         </p:nvSpPr>
@@ -3759,7 +3783,7 @@
       </p:sp>
       <p:sp>
         <p:nvSpPr>
-          <p:cNvPr id="45" name="Text 35"/>
+          <p:cNvPr id="46" name="Text 35"/>
           <p:cNvSpPr txBox="1"/>
           <p:nvPr/>
         </p:nvSpPr>
@@ -3844,7 +3868,7 @@
       </p:sp>
       <p:sp>
         <p:nvSpPr>
-          <p:cNvPr id="46" name="Text 36"/>
+          <p:cNvPr id="47" name="Text 36"/>
           <p:cNvSpPr txBox="1"/>
           <p:nvPr/>
         </p:nvSpPr>
@@ -3883,7 +3907,7 @@
       </p:sp>
       <p:sp>
         <p:nvSpPr>
-          <p:cNvPr id="47" name="Shape 37"/>
+          <p:cNvPr id="48" name="Shape 37"/>
           <p:cNvSpPr/>
           <p:nvPr/>
         </p:nvSpPr>
@@ -3906,7 +3930,7 @@
       </p:sp>
       <p:sp>
         <p:nvSpPr>
-          <p:cNvPr id="48" name="Text 38"/>
+          <p:cNvPr id="49" name="Text 38"/>
           <p:cNvSpPr txBox="1"/>
           <p:nvPr/>
         </p:nvSpPr>
@@ -3945,155 +3969,7 @@
       </p:sp>
       <p:pic>
         <p:nvPicPr>
-          <p:cNvPr id="49" name="fig2a_afr_caterpillar" descr="The 49 proteins that differ between African and HI-WH cognitively normal participants, ranked from MME and S100A12 (lower in African participants) to ARSA and APOE4 (higher), each with a bar for the main-model estimate and a dot for each lot (lot 1 orange, filled; lot 2 navy, hollow); every protein has the same sign in both lots.">    </p:cNvPr>
-          <p:cNvPicPr>
-            <a:picLocks noChangeAspect="1"/>
-          </p:cNvPicPr>
-          <p:nvPr/>
-        </p:nvPicPr>
-        <p:blipFill>
-          <a:blip r:embed="rId9"/>
-          <a:stretch>
-            <a:fillRect/>
-          </a:stretch>
-        </p:blipFill>
-        <p:spPr>
-          <a:xfrm>
-            <a:off x="13424593" y="7466076"/>
-            <a:ext cx="6170815" cy="3992880"/>
-          </a:xfrm>
-          <a:prstGeom prst="rect">
-            <a:avLst/>
-          </a:prstGeom>
-        </p:spPr>
-      </p:pic>
-      <p:sp>
-        <p:nvSpPr>
-          <p:cNvPr id="50" name="Text 39"/>
-          <p:cNvSpPr txBox="1"/>
-          <p:nvPr/>
-        </p:nvSpPr>
-        <p:spPr>
-          <a:xfrm>
-            <a:off x="11328400" y="11519916"/>
-            <a:ext cx="10363200" cy="2063496"/>
-          </a:xfrm>
-          <a:prstGeom prst="rect">
-            <a:avLst/>
-          </a:prstGeom>
-          <a:noFill/>
-          <a:ln/>
-        </p:spPr>
-        <p:txBody>
-          <a:bodyPr wrap="square" lIns="0" tIns="0" rIns="0" bIns="0" rtlCol="0" anchor="t"/>
-          <a:lstStyle/>
-          <a:p>
-            <a:pPr marL="304800" indent="-304800">
-              <a:spcAft>
-                <a:spcPts val="576"/>
-              </a:spcAft>
-              <a:buSzPct val="100000"/>
-              <a:buChar char="•"/>
-            </a:pPr>
-            <a:r>
-              <a:rPr lang="en-US" sz="2400" dirty="0">
-                <a:solidFill>
-                  <a:srgbClr val="1A1A1A"/>
-                </a:solidFill>
-                <a:latin typeface="Arial" pitchFamily="34" charset="0"/>
-                <a:ea typeface="Arial" pitchFamily="34" charset="-122"/>
-                <a:cs typeface="Arial" pitchFamily="34" charset="-120"/>
-              </a:rPr>
-              <a:t>62 of 126 differ; vs HI-WH at NCI: African 49, AA 38, HI-MU 3</a:t>
-            </a:r>
-            <a:endParaRPr lang="en-US" sz="2400" dirty="0"/>
-          </a:p>
-          <a:p>
-            <a:pPr marL="304800" indent="-304800">
-              <a:spcAft>
-                <a:spcPts val="576"/>
-              </a:spcAft>
-              <a:buSzPct val="100000"/>
-              <a:buChar char="•"/>
-            </a:pPr>
-            <a:r>
-              <a:rPr lang="en-US" sz="2400" dirty="0">
-                <a:solidFill>
-                  <a:srgbClr val="1A1A1A"/>
-                </a:solidFill>
-                <a:latin typeface="Arial" pitchFamily="34" charset="0"/>
-                <a:ea typeface="Arial" pitchFamily="34" charset="-122"/>
-                <a:cs typeface="Arial" pitchFamily="34" charset="-120"/>
-              </a:rPr>
-              <a:t>ρ 0.93 between lots, size ratio 0.99; 19 above 2-fold; lots disagree for 5 (‡), reagent changed for 3 (†): lot 1 shown</a:t>
-            </a:r>
-            <a:endParaRPr lang="en-US" sz="2400" dirty="0"/>
-          </a:p>
-          <a:p>
-            <a:pPr marL="304800" indent="-304800">
-              <a:spcAft>
-                <a:spcPts val="576"/>
-              </a:spcAft>
-              <a:buSzPct val="100000"/>
-              <a:buChar char="•"/>
-            </a:pPr>
-            <a:r>
-              <a:rPr lang="en-US" sz="2400" dirty="0">
-                <a:solidFill>
-                  <a:srgbClr val="1A1A1A"/>
-                </a:solidFill>
-                <a:latin typeface="Arial" pitchFamily="34" charset="0"/>
-                <a:ea typeface="Arial" pitchFamily="34" charset="-122"/>
-                <a:cs typeface="Arial" pitchFamily="34" charset="-120"/>
-              </a:rPr>
-              <a:t>HI-MU, Peruvian and Ecuadorian vs Caribbean: 10 in one site, 22 across three (section 3)</a:t>
-            </a:r>
-            <a:endParaRPr lang="en-US" sz="2400" dirty="0"/>
-          </a:p>
-        </p:txBody>
-      </p:sp>
-      <p:sp>
-        <p:nvSpPr>
-          <p:cNvPr id="51" name="Text 40"/>
-          <p:cNvSpPr txBox="1"/>
-          <p:nvPr/>
-        </p:nvSpPr>
-        <p:spPr>
-          <a:xfrm>
-            <a:off x="11328400" y="13735812"/>
-            <a:ext cx="10363200" cy="832104"/>
-          </a:xfrm>
-          <a:prstGeom prst="rect">
-            <a:avLst/>
-          </a:prstGeom>
-          <a:noFill/>
-          <a:ln/>
-        </p:spPr>
-        <p:txBody>
-          <a:bodyPr wrap="square" lIns="0" tIns="0" rIns="0" bIns="0" rtlCol="0" anchor="t"/>
-          <a:lstStyle/>
-          <a:p>
-            <a:pPr indent="0" marL="0">
-              <a:buNone/>
-            </a:pPr>
-            <a:r>
-              <a:rPr lang="en-US" sz="2800" b="1" dirty="0">
-                <a:solidFill>
-                  <a:srgbClr val="332288"/>
-                </a:solidFill>
-                <a:latin typeface="Arial" pitchFamily="34" charset="0"/>
-                <a:ea typeface="Arial" pitchFamily="34" charset="-122"/>
-                <a:cs typeface="Arial" pitchFamily="34" charset="-120"/>
-              </a:rPr>
-              <a:t>The CHIT1 difference is the allele frequency; for IL6R, about half of it</a:t>
-            </a:r>
-            <a:endParaRPr lang="en-US" sz="2800" dirty="0"/>
-          </a:p>
-        </p:txBody>
-      </p:sp>
-      <p:pic>
-        <p:nvPicPr>
-          <p:cNvPr id="52" name="fig_pqtl_dose_freq" descr="Three proteins in columns. Top row: the protein against the number of copies of its variant, among cognitively normal participants with whole-genome sequence, one line per ancestry group. Bottom row: each group's difference from HI-WH against that group's allele frequency, with the difference the per-allele effect predicts as a dashed line; CHIT1 with the 24-bp duplication, IL6R with Asp358Ala, TIMP3 with rs4339044.">    </p:cNvPr>
+          <p:cNvPr id="50" name="fig2a_afr_caterpillar" descr="The 49 proteins that differ between African and HI-WH cognitively normal participants, ranked from MME and S100A12 (lower in African participants) to ARSA and APOE4 (higher), each with a bar for the main-model estimate and a dot for each lot (lot 1 orange, filled; lot 2 navy, hollow); every protein has the same sign in both lots.">    </p:cNvPr>
           <p:cNvPicPr>
             <a:picLocks noChangeAspect="1"/>
           </p:cNvPicPr>
@@ -4107,8 +3983,8 @@
         </p:blipFill>
         <p:spPr>
           <a:xfrm>
-            <a:off x="13894526" y="14628876"/>
-            <a:ext cx="5230949" cy="3230880"/>
+            <a:off x="13424593" y="7466076"/>
+            <a:ext cx="6170815" cy="3992880"/>
           </a:xfrm>
           <a:prstGeom prst="rect">
             <a:avLst/>
@@ -4117,14 +3993,14 @@
       </p:pic>
       <p:sp>
         <p:nvSpPr>
-          <p:cNvPr id="53" name="Text 41"/>
+          <p:cNvPr id="51" name="Text 39"/>
           <p:cNvSpPr txBox="1"/>
           <p:nvPr/>
         </p:nvSpPr>
         <p:spPr>
           <a:xfrm>
-            <a:off x="11328400" y="17859756"/>
-            <a:ext cx="10363200" cy="1606296"/>
+            <a:off x="11328400" y="11519916"/>
+            <a:ext cx="10363200" cy="2063496"/>
           </a:xfrm>
           <a:prstGeom prst="rect">
             <a:avLst/>
@@ -4136,34 +4012,80 @@
           <a:bodyPr wrap="square" lIns="0" tIns="0" rIns="0" bIns="0" rtlCol="0" anchor="t"/>
           <a:lstStyle/>
           <a:p>
-            <a:pPr indent="0" marL="0">
-              <a:buNone/>
-            </a:pPr>
-            <a:r>
-              <a:rPr lang="en-US" sz="1733" dirty="0">
-                <a:solidFill>
-                  <a:srgbClr val="4A4A4A"/>
-                </a:solidFill>
-                <a:latin typeface="Arial" pitchFamily="34" charset="0"/>
-                <a:ea typeface="Arial" pitchFamily="34" charset="-122"/>
-                <a:cs typeface="Arial" pitchFamily="34" charset="-120"/>
-              </a:rPr>
-              <a:t>Top: by allele dose within group, cognitively normal with WGS. Bottom: each group vs HI-WH against its frequency; dashed = per-allele effect × frequency; % = whole-cohort share. Before / after the genotype enters the model, sequenced participants, both lots in one fit with a lot term: CHIT1 +1.55 to +0.05 log2, IL6R −0.35 to −0.03, TIMP3 −0.13 to +0.01 (cohort −1.23). WGS 2,278 of 4,273; 30 of the 49 have no variant in the WGS set, 9 have one that does not move the protein.</a:t>
-            </a:r>
-            <a:endParaRPr lang="en-US" sz="1733" dirty="0"/>
+            <a:pPr marL="304800" indent="-304800">
+              <a:spcAft>
+                <a:spcPts val="576"/>
+              </a:spcAft>
+              <a:buSzPct val="100000"/>
+              <a:buChar char="•"/>
+            </a:pPr>
+            <a:r>
+              <a:rPr lang="en-US" sz="2400" dirty="0">
+                <a:solidFill>
+                  <a:srgbClr val="1A1A1A"/>
+                </a:solidFill>
+                <a:latin typeface="Arial" pitchFamily="34" charset="0"/>
+                <a:ea typeface="Arial" pitchFamily="34" charset="-122"/>
+                <a:cs typeface="Arial" pitchFamily="34" charset="-120"/>
+              </a:rPr>
+              <a:t>62 of 126 differ; vs HI-WH at NCI: African 49, AA 38, HI-MU 3</a:t>
+            </a:r>
+            <a:endParaRPr lang="en-US" sz="2400" dirty="0"/>
+          </a:p>
+          <a:p>
+            <a:pPr marL="304800" indent="-304800">
+              <a:spcAft>
+                <a:spcPts val="576"/>
+              </a:spcAft>
+              <a:buSzPct val="100000"/>
+              <a:buChar char="•"/>
+            </a:pPr>
+            <a:r>
+              <a:rPr lang="en-US" sz="2400" dirty="0">
+                <a:solidFill>
+                  <a:srgbClr val="1A1A1A"/>
+                </a:solidFill>
+                <a:latin typeface="Arial" pitchFamily="34" charset="0"/>
+                <a:ea typeface="Arial" pitchFamily="34" charset="-122"/>
+                <a:cs typeface="Arial" pitchFamily="34" charset="-120"/>
+              </a:rPr>
+              <a:t>ρ 0.93 between lots, size ratio 0.99; 19 above 2-fold; lots disagree for 5 (‡), reagent changed for 3 (†): lot 1 shown</a:t>
+            </a:r>
+            <a:endParaRPr lang="en-US" sz="2400" dirty="0"/>
+          </a:p>
+          <a:p>
+            <a:pPr marL="304800" indent="-304800">
+              <a:spcAft>
+                <a:spcPts val="576"/>
+              </a:spcAft>
+              <a:buSzPct val="100000"/>
+              <a:buChar char="•"/>
+            </a:pPr>
+            <a:r>
+              <a:rPr lang="en-US" sz="2400" dirty="0">
+                <a:solidFill>
+                  <a:srgbClr val="1A1A1A"/>
+                </a:solidFill>
+                <a:latin typeface="Arial" pitchFamily="34" charset="0"/>
+                <a:ea typeface="Arial" pitchFamily="34" charset="-122"/>
+                <a:cs typeface="Arial" pitchFamily="34" charset="-120"/>
+              </a:rPr>
+              <a:t>HI-MU, Peruvian and Ecuadorian vs Caribbean: 10 in one site, 22 across three (section 3)</a:t>
+            </a:r>
+            <a:endParaRPr lang="en-US" sz="2400" dirty="0"/>
           </a:p>
         </p:txBody>
       </p:sp>
       <p:sp>
         <p:nvSpPr>
-          <p:cNvPr id="54" name="Text 42"/>
+          <p:cNvPr id="52" name="Text 40"/>
           <p:cNvSpPr txBox="1"/>
           <p:nvPr/>
         </p:nvSpPr>
         <p:spPr>
           <a:xfrm>
-            <a:off x="22199600" y="5821680"/>
-            <a:ext cx="10363200" cy="495300"/>
+            <a:off x="11328400" y="13735812"/>
+            <a:ext cx="10363200" cy="832104"/>
           </a:xfrm>
           <a:prstGeom prst="rect">
             <a:avLst/>
@@ -4179,6 +4101,108 @@
               <a:buNone/>
             </a:pPr>
             <a:r>
+              <a:rPr lang="en-US" sz="2800" b="1" dirty="0">
+                <a:solidFill>
+                  <a:srgbClr val="332288"/>
+                </a:solidFill>
+                <a:latin typeface="Arial" pitchFamily="34" charset="0"/>
+                <a:ea typeface="Arial" pitchFamily="34" charset="-122"/>
+                <a:cs typeface="Arial" pitchFamily="34" charset="-120"/>
+              </a:rPr>
+              <a:t>The CHIT1 difference is the allele frequency; for IL6R, about half of it</a:t>
+            </a:r>
+            <a:endParaRPr lang="en-US" sz="2800" dirty="0"/>
+          </a:p>
+        </p:txBody>
+      </p:sp>
+      <p:pic>
+        <p:nvPicPr>
+          <p:cNvPr id="53" name="fig_pqtl_dose_freq" descr="Three proteins in columns. Top row: the protein against the number of copies of its variant, among cognitively normal participants with whole-genome sequence, one line per ancestry group. Bottom row: each group's difference from HI-WH against that group's allele frequency, with the difference the per-allele effect predicts as a dashed line; CHIT1 with the 24-bp duplication, IL6R with Asp358Ala, TIMP3 with rs4339044.">    </p:cNvPr>
+          <p:cNvPicPr>
+            <a:picLocks noChangeAspect="1"/>
+          </p:cNvPicPr>
+          <p:nvPr/>
+        </p:nvPicPr>
+        <p:blipFill>
+          <a:blip r:embed="rId11"/>
+          <a:stretch>
+            <a:fillRect/>
+          </a:stretch>
+        </p:blipFill>
+        <p:spPr>
+          <a:xfrm>
+            <a:off x="13894526" y="14628876"/>
+            <a:ext cx="5230949" cy="3230880"/>
+          </a:xfrm>
+          <a:prstGeom prst="rect">
+            <a:avLst/>
+          </a:prstGeom>
+        </p:spPr>
+      </p:pic>
+      <p:sp>
+        <p:nvSpPr>
+          <p:cNvPr id="54" name="Text 41"/>
+          <p:cNvSpPr txBox="1"/>
+          <p:nvPr/>
+        </p:nvSpPr>
+        <p:spPr>
+          <a:xfrm>
+            <a:off x="11328400" y="17859756"/>
+            <a:ext cx="10363200" cy="1606296"/>
+          </a:xfrm>
+          <a:prstGeom prst="rect">
+            <a:avLst/>
+          </a:prstGeom>
+          <a:noFill/>
+          <a:ln/>
+        </p:spPr>
+        <p:txBody>
+          <a:bodyPr wrap="square" lIns="0" tIns="0" rIns="0" bIns="0" rtlCol="0" anchor="t"/>
+          <a:lstStyle/>
+          <a:p>
+            <a:pPr indent="0" marL="0">
+              <a:buNone/>
+            </a:pPr>
+            <a:r>
+              <a:rPr lang="en-US" sz="1733" dirty="0">
+                <a:solidFill>
+                  <a:srgbClr val="4A4A4A"/>
+                </a:solidFill>
+                <a:latin typeface="Arial" pitchFamily="34" charset="0"/>
+                <a:ea typeface="Arial" pitchFamily="34" charset="-122"/>
+                <a:cs typeface="Arial" pitchFamily="34" charset="-120"/>
+              </a:rPr>
+              <a:t>Top: by allele dose within group, cognitively normal with WGS. Bottom: each group vs HI-WH against its frequency; dashed = per-allele effect × frequency; % = whole-cohort share. Before / after the genotype enters the model, sequenced participants, both lots in one fit with a lot term: CHIT1 +1.55 to +0.05 log2, IL6R −0.35 to −0.03, TIMP3 −0.13 to +0.01 (cohort −1.23). WGS 2,278 of 4,273; 30 of the 49 have no variant in the WGS set, 9 have one that does not move the protein.</a:t>
+            </a:r>
+            <a:endParaRPr lang="en-US" sz="1733" dirty="0"/>
+          </a:p>
+        </p:txBody>
+      </p:sp>
+      <p:sp>
+        <p:nvSpPr>
+          <p:cNvPr id="55" name="Text 42"/>
+          <p:cNvSpPr txBox="1"/>
+          <p:nvPr/>
+        </p:nvSpPr>
+        <p:spPr>
+          <a:xfrm>
+            <a:off x="22199600" y="5821680"/>
+            <a:ext cx="10363200" cy="495300"/>
+          </a:xfrm>
+          <a:prstGeom prst="rect">
+            <a:avLst/>
+          </a:prstGeom>
+          <a:noFill/>
+          <a:ln/>
+        </p:spPr>
+        <p:txBody>
+          <a:bodyPr wrap="square" lIns="0" tIns="0" rIns="0" bIns="0" rtlCol="0" anchor="t"/>
+          <a:lstStyle/>
+          <a:p>
+            <a:pPr indent="0" marL="0">
+              <a:buNone/>
+            </a:pPr>
+            <a:r>
               <a:rPr lang="en-US" sz="3333" b="1" dirty="0">
                 <a:solidFill>
                   <a:srgbClr val="1F2A44"/>
@@ -4195,7 +4219,7 @@
       </p:sp>
       <p:sp>
         <p:nvSpPr>
-          <p:cNvPr id="55" name="Shape 43"/>
+          <p:cNvPr id="56" name="Shape 43"/>
           <p:cNvSpPr/>
           <p:nvPr/>
         </p:nvSpPr>
@@ -4218,7 +4242,7 @@
       </p:sp>
       <p:sp>
         <p:nvSpPr>
-          <p:cNvPr id="56" name="Text 44"/>
+          <p:cNvPr id="57" name="Text 44"/>
           <p:cNvSpPr txBox="1"/>
           <p:nvPr/>
         </p:nvSpPr>
@@ -4257,152 +4281,7 @@
       </p:sp>
       <p:pic>
         <p:nvPicPr>
-          <p:cNvPr id="57" name="fig4b_stage_by_group" descr="Level at each diagnosis stage, NCI, MCI and AD, in each group, relative to HI-WH cognitively normal, for pTau-217, BD-pTau-217, NEFL and GFAP; lot 1 in the top row, lot 2 below. p-tau rises from NCI to AD in every group, least in African participants; NEFL and GFAP rise in every group.">    </p:cNvPr>
-          <p:cNvPicPr>
-            <a:picLocks noChangeAspect="1"/>
-          </p:cNvPicPr>
-          <p:nvPr/>
-        </p:nvPicPr>
-        <p:blipFill>
-          <a:blip r:embed="rId11"/>
-          <a:stretch>
-            <a:fillRect/>
-          </a:stretch>
-        </p:blipFill>
-        <p:spPr>
-          <a:xfrm>
-            <a:off x="22199600" y="7882128"/>
-            <a:ext cx="10363200" cy="4267200"/>
-          </a:xfrm>
-          <a:prstGeom prst="rect">
-            <a:avLst/>
-          </a:prstGeom>
-        </p:spPr>
-      </p:pic>
-      <p:sp>
-        <p:nvSpPr>
-          <p:cNvPr id="58" name="Text 45"/>
-          <p:cNvSpPr txBox="1"/>
-          <p:nvPr/>
-        </p:nvSpPr>
-        <p:spPr>
-          <a:xfrm>
-            <a:off x="22199600" y="12149328"/>
-            <a:ext cx="10363200" cy="318516"/>
-          </a:xfrm>
-          <a:prstGeom prst="rect">
-            <a:avLst/>
-          </a:prstGeom>
-          <a:noFill/>
-          <a:ln/>
-        </p:spPr>
-        <p:txBody>
-          <a:bodyPr wrap="square" lIns="0" tIns="0" rIns="0" bIns="0" rtlCol="0" anchor="t"/>
-          <a:lstStyle/>
-          <a:p>
-            <a:pPr indent="0" marL="0">
-              <a:buNone/>
-            </a:pPr>
-            <a:r>
-              <a:rPr lang="en-US" sz="1733" dirty="0">
-                <a:solidFill>
-                  <a:srgbClr val="4A4A4A"/>
-                </a:solidFill>
-                <a:latin typeface="Arial" pitchFamily="34" charset="0"/>
-                <a:ea typeface="Arial" pitchFamily="34" charset="-122"/>
-                <a:cs typeface="Arial" pitchFamily="34" charset="-120"/>
-              </a:rPr>
-              <a:t>Cross-sectional: different people at each stage, not one person followed over time.</a:t>
-            </a:r>
-            <a:endParaRPr lang="en-US" sz="1733" dirty="0"/>
-          </a:p>
-        </p:txBody>
-      </p:sp>
-      <p:sp>
-        <p:nvSpPr>
-          <p:cNvPr id="59" name="Text 46"/>
-          <p:cNvSpPr txBox="1"/>
-          <p:nvPr/>
-        </p:nvSpPr>
-        <p:spPr>
-          <a:xfrm>
-            <a:off x="22199600" y="12528804"/>
-            <a:ext cx="10363200" cy="847344"/>
-          </a:xfrm>
-          <a:prstGeom prst="rect">
-            <a:avLst/>
-          </a:prstGeom>
-          <a:noFill/>
-          <a:ln/>
-        </p:spPr>
-        <p:txBody>
-          <a:bodyPr wrap="square" lIns="0" tIns="0" rIns="0" bIns="0" rtlCol="0" anchor="t"/>
-          <a:lstStyle/>
-          <a:p>
-            <a:pPr marL="304800" indent="-304800">
-              <a:spcAft>
-                <a:spcPts val="576"/>
-              </a:spcAft>
-              <a:buSzPct val="100000"/>
-              <a:buChar char="•"/>
-            </a:pPr>
-            <a:r>
-              <a:rPr lang="en-US" sz="2400" dirty="0">
-                <a:solidFill>
-                  <a:srgbClr val="1A1A1A"/>
-                </a:solidFill>
-                <a:latin typeface="Arial" pitchFamily="34" charset="0"/>
-                <a:ea typeface="Arial" pitchFamily="34" charset="-122"/>
-                <a:cs typeface="Arial" pitchFamily="34" charset="-120"/>
-              </a:rPr>
-              <a:t>12 group × diagnosis interactions of 126; BD-pTau-217 holds in lot 2 alone (p 0.002), pTau-217 and NEFL do not</a:t>
-            </a:r>
-            <a:endParaRPr lang="en-US" sz="2400" dirty="0"/>
-          </a:p>
-        </p:txBody>
-      </p:sp>
-      <p:sp>
-        <p:nvSpPr>
-          <p:cNvPr id="60" name="Text 47"/>
-          <p:cNvSpPr txBox="1"/>
-          <p:nvPr/>
-        </p:nvSpPr>
-        <p:spPr>
-          <a:xfrm>
-            <a:off x="22199600" y="13528548"/>
-            <a:ext cx="10363200" cy="832104"/>
-          </a:xfrm>
-          <a:prstGeom prst="rect">
-            <a:avLst/>
-          </a:prstGeom>
-          <a:noFill/>
-          <a:ln/>
-        </p:spPr>
-        <p:txBody>
-          <a:bodyPr wrap="square" lIns="0" tIns="0" rIns="0" bIns="0" rtlCol="0" anchor="t"/>
-          <a:lstStyle/>
-          <a:p>
-            <a:pPr indent="0" marL="0">
-              <a:buNone/>
-            </a:pPr>
-            <a:r>
-              <a:rPr lang="en-US" sz="2800" b="1" dirty="0">
-                <a:solidFill>
-                  <a:srgbClr val="332288"/>
-                </a:solidFill>
-                <a:latin typeface="Arial" pitchFamily="34" charset="0"/>
-                <a:ea typeface="Arial" pitchFamily="34" charset="-122"/>
-                <a:cs typeface="Arial" pitchFamily="34" charset="-120"/>
-              </a:rPr>
-              <a:t>One BD-pTau-217 cut flags 5 to 10% of normals in every group, and fewer clinical AD at most African sites</a:t>
-            </a:r>
-            <a:endParaRPr lang="en-US" sz="2800" dirty="0"/>
-          </a:p>
-        </p:txBody>
-      </p:sp>
-      <p:pic>
-        <p:nvPicPr>
-          <p:cNvPr id="61" name="fig6_cutpoint_by_group" descr="Percent of clinical AD (filled) and cognitively normal (hollow) participants above a cut-point set at the HI-WH normals' 90th percentile within lot, by group, for five markers in each lot; for BD-pTau-217 the normals sit at 5 to 10 percent in every group, and fewer African participants with clinical AD are above the cut.">    </p:cNvPr>
+          <p:cNvPr id="58" name="fig4b_stage_by_group" descr="Level at each diagnosis stage, NCI, MCI and AD, in each group, relative to HI-WH cognitively normal, for pTau-217, BD-pTau-217, NEFL and GFAP; lot 1 in the top row, lot 2 below. p-tau rises from NCI to AD in every group, least in African participants; NEFL and GFAP rise in every group.">    </p:cNvPr>
           <p:cNvPicPr>
             <a:picLocks noChangeAspect="1"/>
           </p:cNvPicPr>
@@ -4416,8 +4295,8 @@
         </p:blipFill>
         <p:spPr>
           <a:xfrm>
-            <a:off x="22199600" y="14421612"/>
-            <a:ext cx="10363200" cy="3901440"/>
+            <a:off x="22199600" y="7882128"/>
+            <a:ext cx="10363200" cy="4267200"/>
           </a:xfrm>
           <a:prstGeom prst="rect">
             <a:avLst/>
@@ -4426,14 +4305,14 @@
       </p:pic>
       <p:sp>
         <p:nvSpPr>
-          <p:cNvPr id="62" name="Text 48"/>
+          <p:cNvPr id="59" name="Text 45"/>
           <p:cNvSpPr txBox="1"/>
           <p:nvPr/>
         </p:nvSpPr>
         <p:spPr>
           <a:xfrm>
-            <a:off x="22199600" y="18323052"/>
-            <a:ext cx="10363200" cy="1091184"/>
+            <a:off x="22199600" y="12149328"/>
+            <a:ext cx="10363200" cy="318516"/>
           </a:xfrm>
           <a:prstGeom prst="rect">
             <a:avLst/>
@@ -4457,7 +4336,7 @@
                 <a:ea typeface="Arial" pitchFamily="34" charset="-122"/>
                 <a:cs typeface="Arial" pitchFamily="34" charset="-120"/>
               </a:rPr>
-              <a:t>Cut: 90th percentile of HI-WH cognitively normal, within lot (10th for Aβ42). BD-pTau-217, clinical AD above the cut: African 30% vs 43 to 52% (lot 1), 41% vs 62 to 75% (lot 2; HI-WH 28 AD / 58 NCI, HI-MU 21 / 82); by site in lot 2, 5 of 8 African sites 31 to 44%, 3 (50 to 75%) with the other groups’ 50 to 76%; the same pattern on pTau-217 and BD-pTau-181.</a:t>
+              <a:t>Cross-sectional: different people at each stage, not one person followed over time.</a:t>
             </a:r>
             <a:endParaRPr lang="en-US" sz="1733" dirty="0"/>
           </a:p>
@@ -4465,14 +4344,14 @@
       </p:sp>
       <p:sp>
         <p:nvSpPr>
-          <p:cNvPr id="63" name="Text 49"/>
+          <p:cNvPr id="60" name="Text 46"/>
           <p:cNvSpPr txBox="1"/>
           <p:nvPr/>
         </p:nvSpPr>
         <p:spPr>
           <a:xfrm>
-            <a:off x="33070800" y="5821680"/>
-            <a:ext cx="10363200" cy="495300"/>
+            <a:off x="22199600" y="12528804"/>
+            <a:ext cx="10363200" cy="847344"/>
           </a:xfrm>
           <a:prstGeom prst="rect">
             <a:avLst/>
@@ -4484,6 +4363,151 @@
           <a:bodyPr wrap="square" lIns="0" tIns="0" rIns="0" bIns="0" rtlCol="0" anchor="t"/>
           <a:lstStyle/>
           <a:p>
+            <a:pPr marL="304800" indent="-304800">
+              <a:spcAft>
+                <a:spcPts val="576"/>
+              </a:spcAft>
+              <a:buSzPct val="100000"/>
+              <a:buChar char="•"/>
+            </a:pPr>
+            <a:r>
+              <a:rPr lang="en-US" sz="2400" dirty="0">
+                <a:solidFill>
+                  <a:srgbClr val="1A1A1A"/>
+                </a:solidFill>
+                <a:latin typeface="Arial" pitchFamily="34" charset="0"/>
+                <a:ea typeface="Arial" pitchFamily="34" charset="-122"/>
+                <a:cs typeface="Arial" pitchFamily="34" charset="-120"/>
+              </a:rPr>
+              <a:t>12 group × diagnosis interactions of 126; BD-pTau-217 holds in lot 2 alone (p 0.002), pTau-217 and NEFL do not</a:t>
+            </a:r>
+            <a:endParaRPr lang="en-US" sz="2400" dirty="0"/>
+          </a:p>
+        </p:txBody>
+      </p:sp>
+      <p:sp>
+        <p:nvSpPr>
+          <p:cNvPr id="61" name="Text 47"/>
+          <p:cNvSpPr txBox="1"/>
+          <p:nvPr/>
+        </p:nvSpPr>
+        <p:spPr>
+          <a:xfrm>
+            <a:off x="22199600" y="13528548"/>
+            <a:ext cx="10363200" cy="832104"/>
+          </a:xfrm>
+          <a:prstGeom prst="rect">
+            <a:avLst/>
+          </a:prstGeom>
+          <a:noFill/>
+          <a:ln/>
+        </p:spPr>
+        <p:txBody>
+          <a:bodyPr wrap="square" lIns="0" tIns="0" rIns="0" bIns="0" rtlCol="0" anchor="t"/>
+          <a:lstStyle/>
+          <a:p>
+            <a:pPr indent="0" marL="0">
+              <a:buNone/>
+            </a:pPr>
+            <a:r>
+              <a:rPr lang="en-US" sz="2800" b="1" dirty="0">
+                <a:solidFill>
+                  <a:srgbClr val="332288"/>
+                </a:solidFill>
+                <a:latin typeface="Arial" pitchFamily="34" charset="0"/>
+                <a:ea typeface="Arial" pitchFamily="34" charset="-122"/>
+                <a:cs typeface="Arial" pitchFamily="34" charset="-120"/>
+              </a:rPr>
+              <a:t>One BD-pTau-217 cut flags 5 to 10% of normals in every group, and fewer clinical AD at most African sites</a:t>
+            </a:r>
+            <a:endParaRPr lang="en-US" sz="2800" dirty="0"/>
+          </a:p>
+        </p:txBody>
+      </p:sp>
+      <p:pic>
+        <p:nvPicPr>
+          <p:cNvPr id="62" name="fig6_cutpoint_by_group" descr="Percent of clinical AD (filled) and cognitively normal (hollow) participants above a cut-point set at the HI-WH normals' 90th percentile within lot, by group, for five markers in each lot; for BD-pTau-217 the normals sit at 5 to 10 percent in every group, and fewer African participants with clinical AD are above the cut.">    </p:cNvPr>
+          <p:cNvPicPr>
+            <a:picLocks noChangeAspect="1"/>
+          </p:cNvPicPr>
+          <p:nvPr/>
+        </p:nvPicPr>
+        <p:blipFill>
+          <a:blip r:embed="rId13"/>
+          <a:stretch>
+            <a:fillRect/>
+          </a:stretch>
+        </p:blipFill>
+        <p:spPr>
+          <a:xfrm>
+            <a:off x="22199600" y="14421612"/>
+            <a:ext cx="10363200" cy="3901440"/>
+          </a:xfrm>
+          <a:prstGeom prst="rect">
+            <a:avLst/>
+          </a:prstGeom>
+        </p:spPr>
+      </p:pic>
+      <p:sp>
+        <p:nvSpPr>
+          <p:cNvPr id="63" name="Text 48"/>
+          <p:cNvSpPr txBox="1"/>
+          <p:nvPr/>
+        </p:nvSpPr>
+        <p:spPr>
+          <a:xfrm>
+            <a:off x="22199600" y="18323052"/>
+            <a:ext cx="10363200" cy="1091184"/>
+          </a:xfrm>
+          <a:prstGeom prst="rect">
+            <a:avLst/>
+          </a:prstGeom>
+          <a:noFill/>
+          <a:ln/>
+        </p:spPr>
+        <p:txBody>
+          <a:bodyPr wrap="square" lIns="0" tIns="0" rIns="0" bIns="0" rtlCol="0" anchor="t"/>
+          <a:lstStyle/>
+          <a:p>
+            <a:pPr indent="0" marL="0">
+              <a:buNone/>
+            </a:pPr>
+            <a:r>
+              <a:rPr lang="en-US" sz="1733" dirty="0">
+                <a:solidFill>
+                  <a:srgbClr val="4A4A4A"/>
+                </a:solidFill>
+                <a:latin typeface="Arial" pitchFamily="34" charset="0"/>
+                <a:ea typeface="Arial" pitchFamily="34" charset="-122"/>
+                <a:cs typeface="Arial" pitchFamily="34" charset="-120"/>
+              </a:rPr>
+              <a:t>Cut: 90th percentile of HI-WH cognitively normal, within lot (10th for Aβ42). BD-pTau-217, clinical AD above the cut: African 30% vs 43 to 52% (lot 1), 41% vs 62 to 75% (lot 2; HI-WH 28 AD / 58 NCI, HI-MU 21 / 82); by site in lot 2, 5 of 8 African sites 31 to 44%, 3 (50 to 75%) with the other groups’ 50 to 76%; the same pattern on pTau-217 and BD-pTau-181.</a:t>
+            </a:r>
+            <a:endParaRPr lang="en-US" sz="1733" dirty="0"/>
+          </a:p>
+        </p:txBody>
+      </p:sp>
+      <p:sp>
+        <p:nvSpPr>
+          <p:cNvPr id="64" name="Text 49"/>
+          <p:cNvSpPr txBox="1"/>
+          <p:nvPr/>
+        </p:nvSpPr>
+        <p:spPr>
+          <a:xfrm>
+            <a:off x="33070800" y="5821680"/>
+            <a:ext cx="10363200" cy="495300"/>
+          </a:xfrm>
+          <a:prstGeom prst="rect">
+            <a:avLst/>
+          </a:prstGeom>
+          <a:noFill/>
+          <a:ln/>
+        </p:spPr>
+        <p:txBody>
+          <a:bodyPr wrap="square" lIns="0" tIns="0" rIns="0" bIns="0" rtlCol="0" anchor="t"/>
+          <a:lstStyle/>
+          <a:p>
             <a:pPr indent="0" marL="0">
               <a:buNone/>
             </a:pPr>
@@ -4504,7 +4528,7 @@
       </p:sp>
       <p:sp>
         <p:nvSpPr>
-          <p:cNvPr id="64" name="Shape 50"/>
+          <p:cNvPr id="65" name="Shape 50"/>
           <p:cNvSpPr/>
           <p:nvPr/>
         </p:nvSpPr>
@@ -4527,7 +4551,7 @@
       </p:sp>
       <p:sp>
         <p:nvSpPr>
-          <p:cNvPr id="65" name="Text 51"/>
+          <p:cNvPr id="66" name="Text 51"/>
           <p:cNvSpPr txBox="1"/>
           <p:nvPr/>
         </p:nvSpPr>
@@ -4566,14 +4590,14 @@
       </p:sp>
       <p:pic>
         <p:nvPicPr>
-          <p:cNvPr id="66" name="fig5_regional" descr="Left, Peruvian and Ecuadorian minus Caribbean among HI-MU: 24 proteins, each with the estimate over all sites, site in the model (filled), and inside one New York site (hollow); the 10 that differ inside the one site have bold names coloured by function (IL13, CCL17, SAA1, TAFA5, VEGFA, CST3, IL6, IL6R, PDGFRB, MME), the 14 that differ only across sites are grey. Right, East minus West Africa with site in the model: CCL13, MSLN, FOLR1, NPTX1, YWHAZ.">    </p:cNvPr>
+          <p:cNvPr id="67" name="fig5_regional" descr="Left, Peruvian and Ecuadorian minus Caribbean among HI-MU: 24 proteins, each with the estimate over all sites, site in the model (filled), and inside one New York site (hollow); the 10 that differ inside the one site have bold names coloured by function (IL13, CCL17, SAA1, TAFA5, VEGFA, CST3, IL6, IL6R, PDGFRB, MME), the 14 that differ only across sites are grey. Right, East minus West Africa with site in the model: CCL13, MSLN, FOLR1, NPTX1, YWHAZ.">    </p:cNvPr>
           <p:cNvPicPr>
             <a:picLocks noChangeAspect="1"/>
           </p:cNvPicPr>
           <p:nvPr/>
         </p:nvPicPr>
         <p:blipFill>
-          <a:blip r:embed="rId13"/>
+          <a:blip r:embed="rId14"/>
           <a:stretch>
             <a:fillRect/>
           </a:stretch>
@@ -4590,7 +4614,7 @@
       </p:pic>
       <p:sp>
         <p:nvSpPr>
-          <p:cNvPr id="67" name="Text 52"/>
+          <p:cNvPr id="68" name="Text 52"/>
           <p:cNvSpPr txBox="1"/>
           <p:nvPr/>
         </p:nvSpPr>
@@ -4629,7 +4653,7 @@
       </p:sp>
       <p:sp>
         <p:nvSpPr>
-          <p:cNvPr id="68" name="Text 53"/>
+          <p:cNvPr id="69" name="Text 53"/>
           <p:cNvSpPr txBox="1"/>
           <p:nvPr/>
         </p:nvSpPr>
@@ -4693,7 +4717,7 @@
       </p:sp>
       <p:sp>
         <p:nvSpPr>
-          <p:cNvPr id="69" name="CAVEATS"/>
+          <p:cNvPr id="70" name="CAVEATS"/>
           <p:cNvSpPr/>
           <p:nvPr/>
         </p:nvSpPr>
@@ -4718,7 +4742,7 @@
       </p:sp>
       <p:sp>
         <p:nvSpPr>
-          <p:cNvPr id="70" name="Text 55"/>
+          <p:cNvPr id="71" name="Text 55"/>
           <p:cNvSpPr txBox="1"/>
           <p:nvPr/>
         </p:nvSpPr>
@@ -4757,7 +4781,7 @@
       </p:sp>
       <p:sp>
         <p:nvSpPr>
-          <p:cNvPr id="71" name="Text 56"/>
+          <p:cNvPr id="72" name="Text 56"/>
           <p:cNvSpPr txBox="1"/>
           <p:nvPr/>
         </p:nvSpPr>
@@ -4863,7 +4887,7 @@
       </p:sp>
       <p:sp>
         <p:nvSpPr>
-          <p:cNvPr id="72" name="SUPPLEMENT"/>
+          <p:cNvPr id="73" name="SUPPLEMENT"/>
           <p:cNvSpPr/>
           <p:nvPr/>
         </p:nvSpPr>
@@ -4888,7 +4912,7 @@
       </p:sp>
       <p:sp>
         <p:nvSpPr>
-          <p:cNvPr id="73" name="Text 58"/>
+          <p:cNvPr id="74" name="Text 58"/>
           <p:cNvSpPr txBox="1"/>
           <p:nvPr/>
         </p:nvSpPr>
@@ -4927,7 +4951,7 @@
       </p:sp>
       <p:sp>
         <p:nvSpPr>
-          <p:cNvPr id="74" name="Text 59"/>
+          <p:cNvPr id="75" name="Text 59"/>
           <p:cNvSpPr txBox="1"/>
           <p:nvPr/>
         </p:nvSpPr>
@@ -4966,14 +4990,14 @@
       </p:sp>
       <p:pic>
         <p:nvPicPr>
-          <p:cNvPr id="75" name="QR supplement" descr="QR code to the public supplement at github.com/emartin-um/ASHG2026-supplement">    </p:cNvPr>
+          <p:cNvPr id="76" name="QR supplement" descr="QR code to the public supplement at github.com/emartin-um/ASHG2026-supplement">    </p:cNvPr>
           <p:cNvPicPr>
             <a:picLocks noChangeAspect="1"/>
           </p:cNvPicPr>
           <p:nvPr/>
         </p:nvPicPr>
         <p:blipFill>
-          <a:blip r:embed="rId14"/>
+          <a:blip r:embed="rId15"/>
           <a:stretch>
             <a:fillRect/>
           </a:stretch>
@@ -4990,7 +5014,7 @@
       </p:pic>
       <p:sp>
         <p:nvSpPr>
-          <p:cNvPr id="76" name="what this means"/>
+          <p:cNvPr id="77" name="what this means"/>
           <p:cNvSpPr/>
           <p:nvPr/>
         </p:nvSpPr>
@@ -5015,7 +5039,7 @@
       </p:sp>
       <p:sp>
         <p:nvSpPr>
-          <p:cNvPr id="77" name="Text 61"/>
+          <p:cNvPr id="78" name="Text 61"/>
           <p:cNvSpPr txBox="1"/>
           <p:nvPr/>
         </p:nvSpPr>
@@ -5094,7 +5118,7 @@
       </p:sp>
       <p:sp>
         <p:nvSpPr>
-          <p:cNvPr id="78" name="Text 62"/>
+          <p:cNvPr id="79" name="Text 62"/>
           <p:cNvSpPr txBox="1"/>
           <p:nvPr/>
         </p:nvSpPr>

</xml_diff>

<commit_message>
Rounds 4 to 7 of 2026-10-15: NPQ named NULISA Protein Quantification in METHODS; Fig 2a as the lot-1 / lot-2 dumbbell; the genotype figure's bottom row within lot, plus the per-lot supplement figures (figS_pqtl_dose_freq_lot1 / _lot2); Fig 4b and Fig 5 refreshed; poster copy as of round 7 (to be replaced by the PowerPoint export on 2026-10-19)
Co-Authored-By: Claude Opus 5.5 <noreply@anthropic.com>
</commit_message>
<xml_diff>
--- a/poster/ASHG2026_Poster_Martin_36x72.pptx
+++ b/poster/ASHG2026_Poster_Martin_36x72.pptx
@@ -3296,11 +3296,11 @@
             <a:avLst/>
           </a:prstGeom>
           <a:solidFill>
-            <a:srgbClr val="4D4D4D"/>
+            <a:srgbClr val="005030"/>
           </a:solidFill>
           <a:ln w="12700">
             <a:solidFill>
-              <a:srgbClr val="4D4D4D"/>
+              <a:srgbClr val="005030"/>
             </a:solidFill>
             <a:prstDash val="solid"/>
           </a:ln>
@@ -3374,11 +3374,11 @@
             <a:avLst/>
           </a:prstGeom>
           <a:solidFill>
-            <a:srgbClr val="E69F00"/>
+            <a:srgbClr val="3F9E8C"/>
           </a:solidFill>
           <a:ln w="12700">
             <a:solidFill>
-              <a:srgbClr val="E69F00"/>
+              <a:srgbClr val="3F9E8C"/>
             </a:solidFill>
             <a:prstDash val="solid"/>
           </a:ln>
@@ -3452,11 +3452,11 @@
             <a:avLst/>
           </a:prstGeom>
           <a:solidFill>
-            <a:srgbClr val="0072B2"/>
+            <a:srgbClr val="B04A10"/>
           </a:solidFill>
           <a:ln w="12700">
             <a:solidFill>
-              <a:srgbClr val="0072B2"/>
+              <a:srgbClr val="B04A10"/>
             </a:solidFill>
             <a:prstDash val="solid"/>
           </a:ln>
@@ -3530,11 +3530,11 @@
             <a:avLst/>
           </a:prstGeom>
           <a:solidFill>
-            <a:srgbClr val="D55E00"/>
+            <a:srgbClr val="F47321"/>
           </a:solidFill>
           <a:ln w="12700">
             <a:solidFill>
-              <a:srgbClr val="D55E00"/>
+              <a:srgbClr val="F47321"/>
             </a:solidFill>
             <a:prstDash val="solid"/>
           </a:ln>
@@ -3641,7 +3641,7 @@
         <p:spPr>
           <a:xfrm>
             <a:off x="457200" y="13598652"/>
-            <a:ext cx="10363200" cy="2776728"/>
+            <a:ext cx="10363200" cy="3206496"/>
           </a:xfrm>
           <a:prstGeom prst="rect">
             <a:avLst/>
@@ -3690,7 +3690,7 @@
                 <a:ea typeface="Arial" pitchFamily="34" charset="-122"/>
                 <a:cs typeface="Arial" pitchFamily="34" charset="-120"/>
               </a:rPr>
-              <a:t>2 reagent lots, each fitted alone: lot 1, 2,467 participants (2025); lot 2, 1,806 (2026)</a:t>
+              <a:t>NPQ: NULISA Protein Quantification, a log2 relative level</a:t>
             </a:r>
             <a:endParaRPr lang="en-US" sz="2400" dirty="0"/>
           </a:p>
@@ -3711,6 +3711,27 @@
                 <a:ea typeface="Arial" pitchFamily="34" charset="-122"/>
                 <a:cs typeface="Arial" pitchFamily="34" charset="-120"/>
               </a:rPr>
+              <a:t>2 reagent lots, each fitted alone: lot 1, 2,467 participants (2025); lot 2, 1,806 (2026)</a:t>
+            </a:r>
+            <a:endParaRPr lang="en-US" sz="2400" dirty="0"/>
+          </a:p>
+          <a:p>
+            <a:pPr marL="304800" indent="-304800">
+              <a:spcAft>
+                <a:spcPts val="576"/>
+              </a:spcAft>
+              <a:buSzPct val="100000"/>
+              <a:buChar char="•"/>
+            </a:pPr>
+            <a:r>
+              <a:rPr lang="en-US" sz="2400" dirty="0">
+                <a:solidFill>
+                  <a:srgbClr val="1A1A1A"/>
+                </a:solidFill>
+                <a:latin typeface="Arial" pitchFamily="34" charset="0"/>
+                <a:ea typeface="Arial" pitchFamily="34" charset="-122"/>
+                <a:cs typeface="Arial" pitchFamily="34" charset="-120"/>
+              </a:rPr>
               <a:t>model: ancestry, sex, age, diagnosis, reads and a blood-cell score, with site and assay run as random effects; ancestry p-values by parametric bootstrap; full methods in the supplement</a:t>
             </a:r>
             <a:endParaRPr lang="en-US" sz="2400" dirty="0"/>
@@ -3725,7 +3746,7 @@
         </p:nvSpPr>
         <p:spPr>
           <a:xfrm>
-            <a:off x="457200" y="16497300"/>
+            <a:off x="457200" y="16927068"/>
             <a:ext cx="10363200" cy="2429256"/>
           </a:xfrm>
           <a:prstGeom prst="rect">
@@ -3750,7 +3771,7 @@
         </p:nvSpPr>
         <p:spPr>
           <a:xfrm>
-            <a:off x="701040" y="16710660"/>
+            <a:off x="701040" y="17140428"/>
             <a:ext cx="9875520" cy="335280"/>
           </a:xfrm>
           <a:prstGeom prst="rect">
@@ -3789,7 +3810,7 @@
         </p:nvSpPr>
         <p:spPr>
           <a:xfrm>
-            <a:off x="701040" y="17068800"/>
+            <a:off x="701040" y="17498568"/>
             <a:ext cx="9875520" cy="1766316"/>
           </a:xfrm>
           <a:prstGeom prst="rect">
@@ -3969,7 +3990,7 @@
       </p:sp>
       <p:pic>
         <p:nvPicPr>
-          <p:cNvPr id="50" name="fig2a_afr_caterpillar" descr="The 49 proteins that differ between African and HI-WH cognitively normal participants, ranked from MME and S100A12 (lower in African participants) to ARSA and APOE4 (higher), each with a bar for the main-model estimate and a dot for each lot (lot 1 orange, filled; lot 2 navy, hollow); every protein has the same sign in both lots.">    </p:cNvPr>
+          <p:cNvPr id="50" name="fig2a_afr_caterpillar" descr="The 49 proteins that differ between African and HI-WH cognitively normal participants, ranked from MME and S100A12 (lower in African participants) to ARSA and APOE4 (higher), each with its lot-1 (orange, filled) and lot-2 (green, hollow) estimate joined by a grey line; every protein has the same sign in both lots.">    </p:cNvPr>
           <p:cNvPicPr>
             <a:picLocks noChangeAspect="1"/>
           </p:cNvPicPr>
@@ -4117,7 +4138,7 @@
       </p:sp>
       <p:pic>
         <p:nvPicPr>
-          <p:cNvPr id="53" name="fig_pqtl_dose_freq" descr="Three proteins in columns. Top row: the protein against the number of copies of its variant, among cognitively normal participants with whole-genome sequence, one line per ancestry group. Bottom row: each group's difference from HI-WH against that group's allele frequency, with the difference the per-allele effect predicts as a dashed line; CHIT1 with the 24-bp duplication, IL6R with Asp358Ala, TIMP3 with rs4339044.">    </p:cNvPr>
+          <p:cNvPr id="53" name="fig_pqtl_dose_freq" descr="Three proteins in columns. Top row: the protein against the number of copies of its variant, among cognitively normal participants with whole-genome sequence, one line per ancestry group. Bottom row: each group's mean NPQ at NCI against that group's allele frequency, with the level expected from HI-WH and the per-allele effect as a dashed line; CHIT1 with the 24-bp duplication, IL6R with Asp358Ala, TIMP3 with rs4339044.">    </p:cNvPr>
           <p:cNvPicPr>
             <a:picLocks noChangeAspect="1"/>
           </p:cNvPicPr>
@@ -4172,7 +4193,7 @@
                 <a:ea typeface="Arial" pitchFamily="34" charset="-122"/>
                 <a:cs typeface="Arial" pitchFamily="34" charset="-120"/>
               </a:rPr>
-              <a:t>Top: by allele dose within group, cognitively normal with WGS. Bottom: each group vs HI-WH against its frequency; dashed = per-allele effect × frequency; % = whole-cohort share. Before / after the genotype enters the model, sequenced participants, both lots in one fit with a lot term: CHIT1 +1.55 to +0.05 log2, IL6R −0.35 to −0.03, TIMP3 −0.13 to +0.01 (cohort −1.23). WGS 2,278 of 4,273; 30 of the 49 have no variant in the WGS set, 9 have one that does not move the protein.</a:t>
+              <a:t>Top: by allele dose within group, cognitively normal with WGS. Bottom: each group's mean NPQ at NCI against its frequency; dashed = expected from the HI-WH level and the per-allele effect; % = whole-cohort share. Before / after the genotype enters the model, sequenced participants, both lots in one fit with a lot term: CHIT1 +1.55 to +0.05 log2, IL6R −0.35 to −0.03, TIMP3 −0.13 to +0.01 (cohort −1.23). WGS 2,278 of 4,273; 30 of the 49 have no variant in the WGS set, 9 have one that does not move the protein.</a:t>
             </a:r>
             <a:endParaRPr lang="en-US" sz="1733" dirty="0"/>
           </a:p>
@@ -4590,7 +4611,7 @@
       </p:sp>
       <p:pic>
         <p:nvPicPr>
-          <p:cNvPr id="67" name="fig5_regional" descr="Left, Peruvian and Ecuadorian minus Caribbean among HI-MU: 24 proteins, each with the estimate over all sites, site in the model (filled), and inside one New York site (hollow); the 10 that differ inside the one site have bold names coloured by function (IL13, CCL17, SAA1, TAFA5, VEGFA, CST3, IL6, IL6R, PDGFRB, MME), the 14 that differ only across sites are grey. Right, East minus West Africa with site in the model: CCL13, MSLN, FOLR1, NPTX1, YWHAZ.">    </p:cNvPr>
+          <p:cNvPr id="67" name="fig5_regional" descr="Left, Peruvian and Ecuadorian minus Caribbean among HI-MU: 24 proteins, each with the estimate over all sites, site in the model (filled), and inside one New York site (hollow); every name coloured by function, a star on the 8 that differ in both designs (IL13, CCL17, TAFA5, VEGFA, IL6, IL6R, PDGFRB, MME); SAA1 and CST3 differ only inside the one site, the other 14 only across sites. Right, East minus West Africa with site in the model: CCL13, MSLN, FOLR1, NPTX1, YWHAZ.">    </p:cNvPr>
           <p:cNvPicPr>
             <a:picLocks noChangeAspect="1"/>
           </p:cNvPicPr>
@@ -4645,7 +4666,7 @@
                 <a:ea typeface="Arial" pitchFamily="34" charset="-122"/>
                 <a:cs typeface="Arial" pitchFamily="34" charset="-120"/>
               </a:rPr>
-              <a:t>Filled: all sites, site in the model (848 HI-MU); hollow: the New York site alone, 53 vs 379. The Peru site holds 197 of the 260 Peruvian and Ecuadorian and no Caribbean; the 14 grey names are all higher in Peruvian and Ecuadorian.</a:t>
+              <a:t>Filled: all sites, site in the model (848 HI-MU); hollow: the New York site alone, 53 vs 379. The Peru site holds 197 of the 260 Peruvian and Ecuadorian and no Caribbean; * = FDR &lt; 0.05 in both; the 14 that differ only across sites are all higher in Peruvian and Ecuadorian.</a:t>
             </a:r>
             <a:endParaRPr lang="en-US" sz="1733" dirty="0"/>
           </a:p>
@@ -4688,7 +4709,7 @@
                 <a:ea typeface="Arial" pitchFamily="34" charset="-122"/>
                 <a:cs typeface="Arial" pitchFamily="34" charset="-120"/>
               </a:rPr>
-              <a:t>East vs West Africa 5; of the 15 bold names, 6 are immune</a:t>
+              <a:t>East vs West Africa 5; 6 of the 10 + 5 are immune</a:t>
             </a:r>
             <a:endParaRPr lang="en-US" sz="2400" dirty="0"/>
           </a:p>

</xml_diff>